<commit_message>
brisken: deliverables/specs/resources backlog (rome-2026, onepilot, sap-assets, lead-gen)
Co-Authored-By: Claude Fable 5 <noreply@anthropic.com>
</commit_message>
<xml_diff>
--- a/workspace/clients/brisken/deliverables/lead-generation/rome-2026/call-collateral/brisken-treasurycentral-sanofi.pptx
+++ b/workspace/clients/brisken/deliverables/lead-generation/rome-2026/call-collateral/brisken-treasurycentral-sanofi.pptx
@@ -6,6 +6,7 @@
   </p:sldMasterIdLst>
   <p:sldIdLst>
     <p:sldId id="256" r:id="rId2"/>
+    <p:sldId id="266" r:id="rId20"/>
     <p:sldId id="257" r:id="rId3"/>
     <p:sldId id="258" r:id="rId4"/>
     <p:sldId id="259" r:id="rId5"/>
@@ -1786,7 +1787,7 @@
       </p:sp>
       <p:pic>
         <p:nvPicPr>
-          <p:cNvPr id="6" name="Image 0" descr="C:/Users/neuma_p1qrsic/Repo/agentic-ops1/.scratch/brisken-logo-light.png">    </p:cNvPr>
+          <p:cNvPr id="6" name="Image 0" descr="C:/Users/neuma_p1qrsic/Repo/agentic-ops1/.scratch/brisken-logo-light.png"/>
           <p:cNvPicPr>
             <a:picLocks noChangeAspect="1"/>
           </p:cNvPicPr>
@@ -1868,7 +1869,7 @@
                 <a:ea typeface="Segoe UI" pitchFamily="34" charset="-122"/>
                 <a:cs typeface="Segoe UI" pitchFamily="34" charset="-120"/>
               </a:rPr>
-              <a:t>Prepared for  </a:t>
+              <a:t xml:space="preserve">Prepared for  </a:t>
             </a:r>
             <a:pPr algn="ctr" indent="0" marL="0">
               <a:buNone/>
@@ -2027,7 +2028,7 @@
                 <a:ea typeface="Segoe UI" pitchFamily="34" charset="-122"/>
                 <a:cs typeface="Segoe UI" pitchFamily="34" charset="-120"/>
               </a:rPr>
-              <a:t>One cockpit for the whole treasury, on your live SAP data. </a:t>
+              <a:t xml:space="preserve">One cockpit for the whole treasury, on your live SAP data. </a:t>
             </a:r>
             <a:pPr indent="0" marL="0">
               <a:lnSpc>
@@ -2079,7 +2080,7 @@
       </p:sp>
       <p:pic>
         <p:nvPicPr>
-          <p:cNvPr id="14" name="Image 1" descr="C:/Users/neuma_p1qrsic/Repo/agentic-ops1/.scratch/icons/database.png">    </p:cNvPr>
+          <p:cNvPr id="14" name="Image 1" descr="C:/Users/neuma_p1qrsic/Repo/agentic-ops1/.scratch/icons/database.png"/>
           <p:cNvPicPr>
             <a:picLocks noChangeAspect="1"/>
           </p:cNvPicPr>
@@ -2256,7 +2257,7 @@
       </p:sp>
       <p:pic>
         <p:nvPicPr>
-          <p:cNvPr id="20" name="Image 2" descr="C:/Users/neuma_p1qrsic/Repo/agentic-ops1/.scratch/icons/gauge.png">    </p:cNvPr>
+          <p:cNvPr id="20" name="Image 2" descr="C:/Users/neuma_p1qrsic/Repo/agentic-ops1/.scratch/icons/gauge.png"/>
           <p:cNvPicPr>
             <a:picLocks noChangeAspect="1"/>
           </p:cNvPicPr>
@@ -2357,7 +2358,7 @@
         </p:nvSpPr>
         <p:spPr>
           <a:xfrm>
-            <a:off x="3072384" y="0"/>
+            <a:off x="3072384" y="1280160"/>
             <a:ext cx="6035040" cy="6035040"/>
           </a:xfrm>
           <a:prstGeom prst="ellipse">
@@ -2384,7 +2385,7 @@
         </p:nvSpPr>
         <p:spPr>
           <a:xfrm>
-            <a:off x="4443984" y="1371600"/>
+            <a:off x="4443984" y="2651760"/>
             <a:ext cx="3291840" cy="3291840"/>
           </a:xfrm>
           <a:prstGeom prst="ellipse">
@@ -2405,7 +2406,7 @@
       </p:sp>
       <p:pic>
         <p:nvPicPr>
-          <p:cNvPr id="4" name="Image 0" descr="C:/Users/neuma_p1qrsic/Repo/agentic-ops1/.scratch/brisken-logo-light.png">    </p:cNvPr>
+          <p:cNvPr id="4" name="Image 0" descr="C:/Users/neuma_p1qrsic/Repo/agentic-ops1/.scratch/brisken-logo-light.png"/>
           <p:cNvPicPr>
             <a:picLocks noChangeAspect="1"/>
           </p:cNvPicPr>
@@ -2419,8 +2420,8 @@
         </p:blipFill>
         <p:spPr>
           <a:xfrm>
-            <a:off x="5312664" y="1371600"/>
-            <a:ext cx="1554480" cy="338328"/>
+            <a:off x="5316443" y="1371600"/>
+            <a:ext cx="1546921" cy="338328"/>
           </a:xfrm>
           <a:prstGeom prst="rect">
             <a:avLst/>
@@ -2460,7 +2461,7 @@
                 <a:ea typeface="Segoe UI Semibold" pitchFamily="34" charset="-122"/>
                 <a:cs typeface="Segoe UI Semibold" pitchFamily="34" charset="-120"/>
               </a:rPr>
-              <a:t>Built to stay done.</a:t>
+              <a:t>Every decision, one cockpit.</a:t>
             </a:r>
             <a:endParaRPr lang="en-US" sz="5200" dirty="0"/>
           </a:p>
@@ -2502,7 +2503,7 @@
                 <a:ea typeface="Segoe UI" pitchFamily="34" charset="-122"/>
                 <a:cs typeface="Segoe UI" pitchFamily="34" charset="-120"/>
               </a:rPr>
-              <a:t>When we talk, we will show TreasuryCentral live on your SAP data: the process, the analytics and the governance, end to end.</a:t>
+              <a:t>When we talk, we'll walk you through how TreasuryCentral runs this: the process, the analytics and the governance, end to end.</a:t>
             </a:r>
             <a:endParaRPr lang="en-US" sz="1700" dirty="0"/>
           </a:p>
@@ -2610,6 +2611,921 @@
               <a:t>brisken.com   ·   Houston, TX</a:t>
             </a:r>
             <a:endParaRPr lang="en-US" sz="1150" dirty="0"/>
+          </a:p>
+        </p:txBody>
+      </p:sp>
+    </p:spTree>
+  </p:cSld>
+  <p:clrMapOvr>
+    <a:masterClrMapping/>
+  </p:clrMapOvr>
+</p:sld>
+</file>
+
+<file path=ppt/slides/slide11.xml><?xml version="1.0" encoding="utf-8"?>
+<p:sld xmlns:a="http://schemas.openxmlformats.org/drawingml/2006/main" xmlns:r="http://schemas.openxmlformats.org/officeDocument/2006/relationships" xmlns:p="http://schemas.openxmlformats.org/presentationml/2006/main">
+  <p:cSld name="Short Version">
+    <p:bg>
+      <p:bgPr>
+        <a:solidFill>
+          <a:srgbClr val="0B0E14"/>
+        </a:solidFill>
+        <a:effectLst/>
+      </p:bgPr>
+    </p:bg>
+    <p:spTree>
+      <p:nvGrpSpPr>
+        <p:cNvPr id="1" name=""/>
+        <p:cNvGrpSpPr/>
+        <p:nvPr/>
+      </p:nvGrpSpPr>
+      <p:grpSpPr>
+        <a:xfrm>
+          <a:off x="0" y="0"/>
+          <a:ext cx="0" cy="0"/>
+          <a:chOff x="0" y="0"/>
+          <a:chExt cx="0" cy="0"/>
+        </a:xfrm>
+      </p:grpSpPr>
+      <p:sp>
+        <p:nvSpPr>
+          <p:cNvPr id="2" name="Shape 2"/>
+          <p:cNvSpPr/>
+          <p:nvPr/>
+        </p:nvSpPr>
+        <p:spPr>
+          <a:xfrm>
+            <a:off x="566928" y="585216"/>
+            <a:ext cx="45720" cy="219456"/>
+          </a:xfrm>
+          <a:prstGeom prst="rect">
+            <a:avLst/>
+          </a:prstGeom>
+          <a:solidFill>
+            <a:srgbClr val="3BE3E0"/>
+          </a:solidFill>
+          <a:ln w="12700">
+            <a:solidFill>
+              <a:srgbClr val="333333"/>
+            </a:solidFill>
+            <a:prstDash val="solid"/>
+          </a:ln>
+        </p:spPr>
+        <p:txBody>
+          <a:bodyPr/>
+          <a:lstStyle/>
+          <a:p>
+            <a:endParaRPr lang="en-US"/>
+          </a:p>
+        </p:txBody>
+      </p:sp>
+      <p:sp>
+        <p:nvSpPr>
+          <p:cNvPr id="3" name="Text 3"/>
+          <p:cNvSpPr/>
+          <p:nvPr/>
+        </p:nvSpPr>
+        <p:spPr>
+          <a:xfrm>
+            <a:off x="713232" y="512064"/>
+            <a:ext cx="8229600" cy="329184"/>
+          </a:xfrm>
+          <a:prstGeom prst="rect">
+            <a:avLst/>
+          </a:prstGeom>
+          <a:noFill/>
+          <a:ln/>
+        </p:spPr>
+        <p:txBody>
+          <a:bodyPr wrap="square" rtlCol="0" anchor="ctr"/>
+          <a:lstStyle/>
+          <a:p>
+            <a:pPr marL="0" indent="0" algn="l">
+              <a:buNone/>
+            </a:pPr>
+            <a:r>
+              <a:rPr lang="en-US" sz="1200" b="1" kern="0" spc="200" dirty="0">
+                <a:solidFill>
+                  <a:srgbClr val="3BE3E0"/>
+                </a:solidFill>
+                <a:latin typeface="Segoe UI Semibold" pitchFamily="34" charset="0"/>
+                <a:ea typeface="Segoe UI Semibold" pitchFamily="34" charset="-122"/>
+                <a:cs typeface="Segoe UI Semibold" pitchFamily="34" charset="-120"/>
+              </a:rPr>
+              <a:t>THE SHORT VERSION</a:t>
+            </a:r>
+          </a:p>
+        </p:txBody>
+      </p:sp>
+      <p:sp>
+        <p:nvSpPr>
+          <p:cNvPr id="4" name="Text 4"/>
+          <p:cNvSpPr/>
+          <p:nvPr/>
+        </p:nvSpPr>
+        <p:spPr>
+          <a:xfrm>
+            <a:off x="566928" y="960120"/>
+            <a:ext cx="10881360" cy="1463040"/>
+          </a:xfrm>
+          <a:prstGeom prst="rect">
+            <a:avLst/>
+          </a:prstGeom>
+          <a:noFill/>
+          <a:ln/>
+        </p:spPr>
+        <p:txBody>
+          <a:bodyPr wrap="square" rtlCol="0" anchor="ctr"/>
+          <a:lstStyle/>
+          <a:p>
+            <a:pPr marL="0" indent="0" algn="l">
+              <a:lnSpc>
+                <a:spcPct val="105000"/>
+              </a:lnSpc>
+              <a:buNone/>
+            </a:pPr>
+            <a:r>
+              <a:rPr lang="en-US" sz="3300" b="1" dirty="0">
+                <a:solidFill>
+                  <a:srgbClr val="F3F6FB"/>
+                </a:solidFill>
+                <a:latin typeface="Segoe UI Semibold" pitchFamily="34" charset="0"/>
+                <a:ea typeface="Segoe UI Semibold" pitchFamily="34" charset="-122"/>
+                <a:cs typeface="Segoe UI Semibold" pitchFamily="34" charset="-120"/>
+              </a:rPr>
+              <a:t>The whole treasury, one cockpit.
+</a:t>
+            </a:r>
+            <a:r>
+              <a:rPr lang="en-US" sz="3300" b="1" dirty="0">
+                <a:solidFill>
+                  <a:srgbClr val="3BE3E0"/>
+                </a:solidFill>
+                <a:latin typeface="Segoe UI Semibold" pitchFamily="34" charset="0"/>
+                <a:ea typeface="Segoe UI Semibold" pitchFamily="34" charset="-122"/>
+                <a:cs typeface="Segoe UI Semibold" pitchFamily="34" charset="-120"/>
+              </a:rPr>
+              <a:t>Here is what that looks like.</a:t>
+            </a:r>
+          </a:p>
+        </p:txBody>
+      </p:sp>
+      <p:sp>
+        <p:nvSpPr>
+          <p:cNvPr id="10" name="Shape 10"/>
+          <p:cNvSpPr/>
+          <p:nvPr/>
+        </p:nvSpPr>
+        <p:spPr>
+          <a:xfrm>
+            <a:off x="566928" y="2590800"/>
+            <a:ext cx="11057839" cy="700000"/>
+          </a:xfrm>
+          <a:prstGeom prst="roundRect">
+            <a:avLst>
+              <a:gd name="adj" fmla="val 8000"/>
+            </a:avLst>
+          </a:prstGeom>
+          <a:solidFill>
+            <a:srgbClr val="141A25"/>
+          </a:solidFill>
+          <a:ln w="13970">
+            <a:solidFill>
+              <a:srgbClr val="36414F"/>
+            </a:solidFill>
+            <a:prstDash val="solid"/>
+          </a:ln>
+        </p:spPr>
+        <p:txBody>
+          <a:bodyPr/>
+          <a:lstStyle/>
+          <a:p>
+            <a:endParaRPr lang="en-US"/>
+          </a:p>
+        </p:txBody>
+      </p:sp>
+      <p:sp>
+        <p:nvSpPr>
+          <p:cNvPr id="11" name="Text 11"/>
+          <p:cNvSpPr/>
+          <p:nvPr/>
+        </p:nvSpPr>
+        <p:spPr>
+          <a:xfrm>
+            <a:off x="886928" y="2712200"/>
+            <a:ext cx="700000" cy="457200"/>
+          </a:xfrm>
+          <a:prstGeom prst="rect">
+            <a:avLst/>
+          </a:prstGeom>
+          <a:noFill/>
+          <a:ln/>
+        </p:spPr>
+        <p:txBody>
+          <a:bodyPr wrap="square" rtlCol="0" anchor="ctr"/>
+          <a:lstStyle/>
+          <a:p>
+            <a:pPr marL="0" indent="0" algn="l">
+              <a:buNone/>
+            </a:pPr>
+            <a:r>
+              <a:rPr lang="en-US" sz="2000" b="1" dirty="0">
+                <a:solidFill>
+                  <a:srgbClr val="3BE3E0"/>
+                </a:solidFill>
+                <a:latin typeface="Segoe UI Semibold" pitchFamily="34" charset="0"/>
+                <a:ea typeface="Segoe UI Semibold" pitchFamily="34" charset="-122"/>
+                <a:cs typeface="Segoe UI Semibold" pitchFamily="34" charset="-120"/>
+              </a:rPr>
+              <a:t>01</a:t>
+            </a:r>
+          </a:p>
+        </p:txBody>
+      </p:sp>
+      <p:sp>
+        <p:nvSpPr>
+          <p:cNvPr id="12" name="Text 12"/>
+          <p:cNvSpPr/>
+          <p:nvPr/>
+        </p:nvSpPr>
+        <p:spPr>
+          <a:xfrm>
+            <a:off x="1686928" y="2636000"/>
+            <a:ext cx="2600000" cy="609600"/>
+          </a:xfrm>
+          <a:prstGeom prst="rect">
+            <a:avLst/>
+          </a:prstGeom>
+          <a:noFill/>
+          <a:ln/>
+        </p:spPr>
+        <p:txBody>
+          <a:bodyPr wrap="square" rtlCol="0" anchor="ctr"/>
+          <a:lstStyle/>
+          <a:p>
+            <a:pPr marL="0" indent="0" algn="l">
+              <a:buNone/>
+            </a:pPr>
+            <a:r>
+              <a:rPr lang="en-US" sz="1500" b="1" dirty="0">
+                <a:solidFill>
+                  <a:srgbClr val="F3F6FB"/>
+                </a:solidFill>
+                <a:latin typeface="Segoe UI Semibold" pitchFamily="34" charset="0"/>
+                <a:ea typeface="Segoe UI Semibold" pitchFamily="34" charset="-122"/>
+                <a:cs typeface="Segoe UI Semibold" pitchFamily="34" charset="-120"/>
+              </a:rPr>
+              <a:t>What this is</a:t>
+            </a:r>
+          </a:p>
+        </p:txBody>
+      </p:sp>
+      <p:sp>
+        <p:nvSpPr>
+          <p:cNvPr id="13" name="Text 13"/>
+          <p:cNvSpPr/>
+          <p:nvPr/>
+        </p:nvSpPr>
+        <p:spPr>
+          <a:xfrm>
+            <a:off x="4486928" y="2636000"/>
+            <a:ext cx="6817839" cy="609600"/>
+          </a:xfrm>
+          <a:prstGeom prst="rect">
+            <a:avLst/>
+          </a:prstGeom>
+          <a:noFill/>
+          <a:ln/>
+        </p:spPr>
+        <p:txBody>
+          <a:bodyPr wrap="square" rtlCol="0" anchor="ctr"/>
+          <a:lstStyle/>
+          <a:p>
+            <a:pPr marL="0" indent="0" algn="l">
+              <a:lnSpc>
+                <a:spcPct val="115000"/>
+              </a:lnSpc>
+              <a:buNone/>
+            </a:pPr>
+            <a:r>
+              <a:rPr lang="en-US" sz="1300" dirty="0">
+                <a:solidFill>
+                  <a:srgbClr val="AAB6C7"/>
+                </a:solidFill>
+                <a:latin typeface="Segoe UI" pitchFamily="34" charset="0"/>
+                <a:ea typeface="Segoe UI" pitchFamily="34" charset="-122"/>
+                <a:cs typeface="Segoe UI" pitchFamily="34" charset="-120"/>
+              </a:rPr>
+              <a:t>TreasuryCentral on OnePilot: one cockpit on your live SAP data, with market data, trading and AI automation in one governed layer.</a:t>
+            </a:r>
+          </a:p>
+        </p:txBody>
+      </p:sp>
+      <p:sp>
+        <p:nvSpPr>
+          <p:cNvPr id="20" name="Shape 20"/>
+          <p:cNvSpPr/>
+          <p:nvPr/>
+        </p:nvSpPr>
+        <p:spPr>
+          <a:xfrm>
+            <a:off x="566928" y="3410800"/>
+            <a:ext cx="11057839" cy="700000"/>
+          </a:xfrm>
+          <a:prstGeom prst="roundRect">
+            <a:avLst>
+              <a:gd name="adj" fmla="val 8000"/>
+            </a:avLst>
+          </a:prstGeom>
+          <a:solidFill>
+            <a:srgbClr val="141A25"/>
+          </a:solidFill>
+          <a:ln w="13970">
+            <a:solidFill>
+              <a:srgbClr val="36414F"/>
+            </a:solidFill>
+            <a:prstDash val="solid"/>
+          </a:ln>
+        </p:spPr>
+        <p:txBody>
+          <a:bodyPr/>
+          <a:lstStyle/>
+          <a:p>
+            <a:endParaRPr lang="en-US"/>
+          </a:p>
+        </p:txBody>
+      </p:sp>
+      <p:sp>
+        <p:nvSpPr>
+          <p:cNvPr id="21" name="Text 21"/>
+          <p:cNvSpPr/>
+          <p:nvPr/>
+        </p:nvSpPr>
+        <p:spPr>
+          <a:xfrm>
+            <a:off x="886928" y="3532200"/>
+            <a:ext cx="700000" cy="457200"/>
+          </a:xfrm>
+          <a:prstGeom prst="rect">
+            <a:avLst/>
+          </a:prstGeom>
+          <a:noFill/>
+          <a:ln/>
+        </p:spPr>
+        <p:txBody>
+          <a:bodyPr wrap="square" rtlCol="0" anchor="ctr"/>
+          <a:lstStyle/>
+          <a:p>
+            <a:pPr marL="0" indent="0" algn="l">
+              <a:buNone/>
+            </a:pPr>
+            <a:r>
+              <a:rPr lang="en-US" sz="2000" b="1" dirty="0">
+                <a:solidFill>
+                  <a:srgbClr val="3BE3E0"/>
+                </a:solidFill>
+                <a:latin typeface="Segoe UI Semibold" pitchFamily="34" charset="0"/>
+                <a:ea typeface="Segoe UI Semibold" pitchFamily="34" charset="-122"/>
+                <a:cs typeface="Segoe UI Semibold" pitchFamily="34" charset="-120"/>
+              </a:rPr>
+              <a:t>02</a:t>
+            </a:r>
+          </a:p>
+        </p:txBody>
+      </p:sp>
+      <p:sp>
+        <p:nvSpPr>
+          <p:cNvPr id="22" name="Text 22"/>
+          <p:cNvSpPr/>
+          <p:nvPr/>
+        </p:nvSpPr>
+        <p:spPr>
+          <a:xfrm>
+            <a:off x="1686928" y="3456000"/>
+            <a:ext cx="2600000" cy="609600"/>
+          </a:xfrm>
+          <a:prstGeom prst="rect">
+            <a:avLst/>
+          </a:prstGeom>
+          <a:noFill/>
+          <a:ln/>
+        </p:spPr>
+        <p:txBody>
+          <a:bodyPr wrap="square" rtlCol="0" anchor="ctr"/>
+          <a:lstStyle/>
+          <a:p>
+            <a:pPr marL="0" indent="0" algn="l">
+              <a:buNone/>
+            </a:pPr>
+            <a:r>
+              <a:rPr lang="en-US" sz="1500" b="1" dirty="0">
+                <a:solidFill>
+                  <a:srgbClr val="F3F6FB"/>
+                </a:solidFill>
+                <a:latin typeface="Segoe UI Semibold" pitchFamily="34" charset="0"/>
+                <a:ea typeface="Segoe UI Semibold" pitchFamily="34" charset="-122"/>
+                <a:cs typeface="Segoe UI Semibold" pitchFamily="34" charset="-120"/>
+              </a:rPr>
+              <a:t>What it replaces</a:t>
+            </a:r>
+          </a:p>
+        </p:txBody>
+      </p:sp>
+      <p:sp>
+        <p:nvSpPr>
+          <p:cNvPr id="23" name="Text 23"/>
+          <p:cNvSpPr/>
+          <p:nvPr/>
+        </p:nvSpPr>
+        <p:spPr>
+          <a:xfrm>
+            <a:off x="4486928" y="3456000"/>
+            <a:ext cx="6817839" cy="609600"/>
+          </a:xfrm>
+          <a:prstGeom prst="rect">
+            <a:avLst/>
+          </a:prstGeom>
+          <a:noFill/>
+          <a:ln/>
+        </p:spPr>
+        <p:txBody>
+          <a:bodyPr wrap="square" rtlCol="0" anchor="ctr"/>
+          <a:lstStyle/>
+          <a:p>
+            <a:pPr marL="0" indent="0" algn="l">
+              <a:lnSpc>
+                <a:spcPct val="115000"/>
+              </a:lnSpc>
+              <a:buNone/>
+            </a:pPr>
+            <a:r>
+              <a:rPr lang="en-US" sz="1300" dirty="0">
+                <a:solidFill>
+                  <a:srgbClr val="AAB6C7"/>
+                </a:solidFill>
+                <a:latin typeface="Segoe UI" pitchFamily="34" charset="0"/>
+                <a:ea typeface="Segoe UI" pitchFamily="34" charset="-122"/>
+                <a:cs typeface="Segoe UI" pitchFamily="34" charset="-120"/>
+              </a:rPr>
+              <a:t>The manual middle between your sources and SAP: re-keyed rates, hand-reconciled positions, values chased across a dozen places.</a:t>
+            </a:r>
+          </a:p>
+        </p:txBody>
+      </p:sp>
+      <p:sp>
+        <p:nvSpPr>
+          <p:cNvPr id="30" name="Shape 30"/>
+          <p:cNvSpPr/>
+          <p:nvPr/>
+        </p:nvSpPr>
+        <p:spPr>
+          <a:xfrm>
+            <a:off x="566928" y="4230800"/>
+            <a:ext cx="11057839" cy="700000"/>
+          </a:xfrm>
+          <a:prstGeom prst="roundRect">
+            <a:avLst>
+              <a:gd name="adj" fmla="val 8000"/>
+            </a:avLst>
+          </a:prstGeom>
+          <a:solidFill>
+            <a:srgbClr val="141A25"/>
+          </a:solidFill>
+          <a:ln w="13970">
+            <a:solidFill>
+              <a:srgbClr val="36414F"/>
+            </a:solidFill>
+            <a:prstDash val="solid"/>
+          </a:ln>
+        </p:spPr>
+        <p:txBody>
+          <a:bodyPr/>
+          <a:lstStyle/>
+          <a:p>
+            <a:endParaRPr lang="en-US"/>
+          </a:p>
+        </p:txBody>
+      </p:sp>
+      <p:sp>
+        <p:nvSpPr>
+          <p:cNvPr id="31" name="Text 31"/>
+          <p:cNvSpPr/>
+          <p:nvPr/>
+        </p:nvSpPr>
+        <p:spPr>
+          <a:xfrm>
+            <a:off x="886928" y="4352200"/>
+            <a:ext cx="700000" cy="457200"/>
+          </a:xfrm>
+          <a:prstGeom prst="rect">
+            <a:avLst/>
+          </a:prstGeom>
+          <a:noFill/>
+          <a:ln/>
+        </p:spPr>
+        <p:txBody>
+          <a:bodyPr wrap="square" rtlCol="0" anchor="ctr"/>
+          <a:lstStyle/>
+          <a:p>
+            <a:pPr marL="0" indent="0" algn="l">
+              <a:buNone/>
+            </a:pPr>
+            <a:r>
+              <a:rPr lang="en-US" sz="2000" b="1" dirty="0">
+                <a:solidFill>
+                  <a:srgbClr val="3BE3E0"/>
+                </a:solidFill>
+                <a:latin typeface="Segoe UI Semibold" pitchFamily="34" charset="0"/>
+                <a:ea typeface="Segoe UI Semibold" pitchFamily="34" charset="-122"/>
+                <a:cs typeface="Segoe UI Semibold" pitchFamily="34" charset="-120"/>
+              </a:rPr>
+              <a:t>03</a:t>
+            </a:r>
+          </a:p>
+        </p:txBody>
+      </p:sp>
+      <p:sp>
+        <p:nvSpPr>
+          <p:cNvPr id="32" name="Text 32"/>
+          <p:cNvSpPr/>
+          <p:nvPr/>
+        </p:nvSpPr>
+        <p:spPr>
+          <a:xfrm>
+            <a:off x="1686928" y="4276000"/>
+            <a:ext cx="2600000" cy="609600"/>
+          </a:xfrm>
+          <a:prstGeom prst="rect">
+            <a:avLst/>
+          </a:prstGeom>
+          <a:noFill/>
+          <a:ln/>
+        </p:spPr>
+        <p:txBody>
+          <a:bodyPr wrap="square" rtlCol="0" anchor="ctr"/>
+          <a:lstStyle/>
+          <a:p>
+            <a:pPr marL="0" indent="0" algn="l">
+              <a:buNone/>
+            </a:pPr>
+            <a:r>
+              <a:rPr lang="en-US" sz="1500" b="1" dirty="0">
+                <a:solidFill>
+                  <a:srgbClr val="F3F6FB"/>
+                </a:solidFill>
+                <a:latin typeface="Segoe UI Semibold" pitchFamily="34" charset="0"/>
+                <a:ea typeface="Segoe UI Semibold" pitchFamily="34" charset="-122"/>
+                <a:cs typeface="Segoe UI Semibold" pitchFamily="34" charset="-120"/>
+              </a:rPr>
+              <a:t>What you get</a:t>
+            </a:r>
+          </a:p>
+        </p:txBody>
+      </p:sp>
+      <p:sp>
+        <p:nvSpPr>
+          <p:cNvPr id="33" name="Text 33"/>
+          <p:cNvSpPr/>
+          <p:nvPr/>
+        </p:nvSpPr>
+        <p:spPr>
+          <a:xfrm>
+            <a:off x="4486928" y="4276000"/>
+            <a:ext cx="6817839" cy="609600"/>
+          </a:xfrm>
+          <a:prstGeom prst="rect">
+            <a:avLst/>
+          </a:prstGeom>
+          <a:noFill/>
+          <a:ln/>
+        </p:spPr>
+        <p:txBody>
+          <a:bodyPr wrap="square" rtlCol="0" anchor="ctr"/>
+          <a:lstStyle/>
+          <a:p>
+            <a:pPr marL="0" indent="0" algn="l">
+              <a:lnSpc>
+                <a:spcPct val="115000"/>
+              </a:lnSpc>
+              <a:buNone/>
+            </a:pPr>
+            <a:r>
+              <a:rPr lang="en-US" sz="1300" dirty="0">
+                <a:solidFill>
+                  <a:srgbClr val="AAB6C7"/>
+                </a:solidFill>
+                <a:latin typeface="Segoe UI" pitchFamily="34" charset="0"/>
+                <a:ea typeface="Segoe UI" pitchFamily="34" charset="-122"/>
+                <a:cs typeface="Segoe UI" pitchFamily="34" charset="-120"/>
+              </a:rPr>
+              <a:t>One clean, governed set of data driving every treasury decision: checked, logged, no code to run it.</a:t>
+            </a:r>
+          </a:p>
+        </p:txBody>
+      </p:sp>
+      <p:sp>
+        <p:nvSpPr>
+          <p:cNvPr id="34" name="Shape 30"/>
+          <p:cNvSpPr/>
+          <p:nvPr/>
+        </p:nvSpPr>
+        <p:spPr>
+          <a:xfrm>
+            <a:off x="566928" y="5050800"/>
+            <a:ext cx="11057839" cy="700000"/>
+          </a:xfrm>
+          <a:prstGeom prst="roundRect">
+            <a:avLst>
+              <a:gd name="adj" fmla="val 8000"/>
+            </a:avLst>
+          </a:prstGeom>
+          <a:solidFill>
+            <a:srgbClr val="141A25"/>
+          </a:solidFill>
+          <a:ln w="13970">
+            <a:solidFill>
+              <a:srgbClr val="36414F"/>
+            </a:solidFill>
+            <a:prstDash val="solid"/>
+          </a:ln>
+        </p:spPr>
+        <p:txBody>
+          <a:bodyPr/>
+          <a:lstStyle/>
+          <a:p>
+            <a:endParaRPr lang="en-US"/>
+          </a:p>
+        </p:txBody>
+      </p:sp>
+      <p:sp>
+        <p:nvSpPr>
+          <p:cNvPr id="35" name="Text 31"/>
+          <p:cNvSpPr/>
+          <p:nvPr/>
+        </p:nvSpPr>
+        <p:spPr>
+          <a:xfrm>
+            <a:off x="886928" y="5172200"/>
+            <a:ext cx="700000" cy="457200"/>
+          </a:xfrm>
+          <a:prstGeom prst="rect">
+            <a:avLst/>
+          </a:prstGeom>
+          <a:noFill/>
+          <a:ln/>
+        </p:spPr>
+        <p:txBody>
+          <a:bodyPr wrap="square" rtlCol="0" anchor="ctr"/>
+          <a:lstStyle/>
+          <a:p>
+            <a:pPr marL="0" indent="0" algn="l">
+              <a:buNone/>
+            </a:pPr>
+            <a:r>
+              <a:rPr lang="en-US" sz="2000" b="1" dirty="0">
+                <a:solidFill>
+                  <a:srgbClr val="3BE3E0"/>
+                </a:solidFill>
+                <a:latin typeface="Segoe UI Semibold" pitchFamily="34" charset="0"/>
+                <a:ea typeface="Segoe UI Semibold" pitchFamily="34" charset="-122"/>
+                <a:cs typeface="Segoe UI Semibold" pitchFamily="34" charset="-120"/>
+              </a:rPr>
+              <a:t>04</a:t>
+            </a:r>
+          </a:p>
+        </p:txBody>
+      </p:sp>
+      <p:sp>
+        <p:nvSpPr>
+          <p:cNvPr id="36" name="Text 32"/>
+          <p:cNvSpPr/>
+          <p:nvPr/>
+        </p:nvSpPr>
+        <p:spPr>
+          <a:xfrm>
+            <a:off x="1686928" y="5096000"/>
+            <a:ext cx="2600000" cy="609600"/>
+          </a:xfrm>
+          <a:prstGeom prst="rect">
+            <a:avLst/>
+          </a:prstGeom>
+          <a:noFill/>
+          <a:ln/>
+        </p:spPr>
+        <p:txBody>
+          <a:bodyPr wrap="square" rtlCol="0" anchor="ctr"/>
+          <a:lstStyle/>
+          <a:p>
+            <a:pPr marL="0" indent="0" algn="l">
+              <a:buNone/>
+            </a:pPr>
+            <a:r>
+              <a:rPr lang="en-US" sz="1500" b="1" dirty="0">
+                <a:solidFill>
+                  <a:srgbClr val="F3F6FB"/>
+                </a:solidFill>
+                <a:latin typeface="Segoe UI Semibold" pitchFamily="34" charset="0"/>
+                <a:ea typeface="Segoe UI Semibold" pitchFamily="34" charset="-122"/>
+                <a:cs typeface="Segoe UI Semibold" pitchFamily="34" charset="-120"/>
+              </a:rPr>
+              <a:t>Who it is for</a:t>
+            </a:r>
+          </a:p>
+        </p:txBody>
+      </p:sp>
+      <p:sp>
+        <p:nvSpPr>
+          <p:cNvPr id="37" name="Text 33"/>
+          <p:cNvSpPr/>
+          <p:nvPr/>
+        </p:nvSpPr>
+        <p:spPr>
+          <a:xfrm>
+            <a:off x="4486928" y="5096000"/>
+            <a:ext cx="6817839" cy="609600"/>
+          </a:xfrm>
+          <a:prstGeom prst="rect">
+            <a:avLst/>
+          </a:prstGeom>
+          <a:noFill/>
+          <a:ln/>
+        </p:spPr>
+        <p:txBody>
+          <a:bodyPr wrap="square" rtlCol="0" anchor="ctr"/>
+          <a:lstStyle/>
+          <a:p>
+            <a:pPr marL="0" indent="0" algn="l">
+              <a:lnSpc>
+                <a:spcPct val="115000"/>
+              </a:lnSpc>
+              <a:buNone/>
+            </a:pPr>
+            <a:r>
+              <a:rPr lang="en-US" sz="1300" dirty="0">
+                <a:solidFill>
+                  <a:srgbClr val="AAB6C7"/>
+                </a:solidFill>
+                <a:latin typeface="Segoe UI" pitchFamily="34" charset="0"/>
+                <a:ea typeface="Segoe UI" pitchFamily="34" charset="-122"/>
+                <a:cs typeface="Segoe UI" pitchFamily="34" charset="-120"/>
+              </a:rPr>
+              <a:t>A global treasury group on SAP: ECC, S/4HANA or TRM, one process, running the same way across the group.</a:t>
+            </a:r>
+          </a:p>
+        </p:txBody>
+      </p:sp>
+      <p:sp>
+        <p:nvSpPr>
+          <p:cNvPr id="40" name="Text 40"/>
+          <p:cNvSpPr/>
+          <p:nvPr/>
+        </p:nvSpPr>
+        <p:spPr>
+          <a:xfrm>
+            <a:off x="566928" y="5871480"/>
+            <a:ext cx="11057839" cy="350520"/>
+          </a:xfrm>
+          <a:prstGeom prst="rect">
+            <a:avLst/>
+          </a:prstGeom>
+          <a:noFill/>
+          <a:ln/>
+        </p:spPr>
+        <p:txBody>
+          <a:bodyPr wrap="square" rtlCol="0" anchor="ctr"/>
+          <a:lstStyle/>
+          <a:p>
+            <a:pPr marL="0" indent="0" algn="l">
+              <a:buNone/>
+            </a:pPr>
+            <a:r>
+              <a:rPr lang="en-US" sz="1600" dirty="0">
+                <a:solidFill>
+                  <a:srgbClr val="3BE3E0"/>
+                </a:solidFill>
+                <a:latin typeface="Segoe UI" pitchFamily="34" charset="0"/>
+                <a:ea typeface="Segoe UI" pitchFamily="34" charset="-122"/>
+                <a:cs typeface="Segoe UI" pitchFamily="34" charset="-120"/>
+              </a:rPr>
+              <a:t>The next page is where you are today. Then the cockpit, its three engines, and why it is safe.</a:t>
+            </a:r>
+          </a:p>
+        </p:txBody>
+      </p:sp>
+      <p:sp>
+        <p:nvSpPr>
+          <p:cNvPr id="41" name="Text 41"/>
+          <p:cNvSpPr/>
+          <p:nvPr/>
+        </p:nvSpPr>
+        <p:spPr>
+          <a:xfrm>
+            <a:off x="566928" y="6400800"/>
+            <a:ext cx="8229600" cy="274320"/>
+          </a:xfrm>
+          <a:prstGeom prst="rect">
+            <a:avLst/>
+          </a:prstGeom>
+          <a:noFill/>
+          <a:ln/>
+        </p:spPr>
+        <p:txBody>
+          <a:bodyPr wrap="square" rtlCol="0" anchor="ctr"/>
+          <a:lstStyle/>
+          <a:p>
+            <a:pPr marL="0" indent="0" algn="l">
+              <a:buNone/>
+            </a:pPr>
+            <a:r>
+              <a:rPr lang="en-US" sz="900" b="1" dirty="0">
+                <a:solidFill>
+                  <a:srgbClr val="AAB6C7"/>
+                </a:solidFill>
+                <a:latin typeface="Segoe UI" pitchFamily="34" charset="0"/>
+                <a:ea typeface="Segoe UI" pitchFamily="34" charset="-122"/>
+                <a:cs typeface="Segoe UI" pitchFamily="34" charset="-120"/>
+              </a:rPr>
+              <a:t>Brisken</a:t>
+            </a:r>
+            <a:r>
+              <a:rPr lang="en-US" sz="900" dirty="0">
+                <a:solidFill>
+                  <a:srgbClr val="7C8A9B"/>
+                </a:solidFill>
+                <a:latin typeface="Segoe UI" pitchFamily="34" charset="0"/>
+                <a:ea typeface="Segoe UI" pitchFamily="34" charset="-122"/>
+                <a:cs typeface="Segoe UI" pitchFamily="34" charset="-120"/>
+              </a:rPr>
+              <a:t xml:space="preserve">   TreasuryCentral, powered by OnePilot</a:t>
+            </a:r>
+          </a:p>
+        </p:txBody>
+      </p:sp>
+      <p:sp>
+        <p:nvSpPr>
+          <p:cNvPr id="42" name="Text 42"/>
+          <p:cNvSpPr/>
+          <p:nvPr/>
+        </p:nvSpPr>
+        <p:spPr>
+          <a:xfrm>
+            <a:off x="10527487" y="6400800"/>
+            <a:ext cx="1097280" cy="274320"/>
+          </a:xfrm>
+          <a:prstGeom prst="rect">
+            <a:avLst/>
+          </a:prstGeom>
+          <a:noFill/>
+          <a:ln/>
+        </p:spPr>
+        <p:txBody>
+          <a:bodyPr wrap="square" rtlCol="0" anchor="ctr"/>
+          <a:lstStyle/>
+          <a:p>
+            <a:pPr marL="0" indent="0" algn="r">
+              <a:buNone/>
+            </a:pPr>
+            <a:r>
+              <a:rPr lang="en-US" sz="900" dirty="0">
+                <a:solidFill>
+                  <a:srgbClr val="AAB6C7"/>
+                </a:solidFill>
+                <a:latin typeface="Segoe UI" pitchFamily="34" charset="0"/>
+                <a:ea typeface="Segoe UI" pitchFamily="34" charset="-122"/>
+                <a:cs typeface="Segoe UI" pitchFamily="34" charset="-120"/>
+              </a:rPr>
+              <a:t>02 / 11</a:t>
+            </a:r>
+          </a:p>
+        </p:txBody>
+      </p:sp>
+      <p:sp>
+        <p:nvSpPr>
+          <p:cNvPr id="43" name="Shape 43"/>
+          <p:cNvSpPr/>
+          <p:nvPr/>
+        </p:nvSpPr>
+        <p:spPr>
+          <a:xfrm>
+            <a:off x="566928" y="6327648"/>
+            <a:ext cx="11057839" cy="0"/>
+          </a:xfrm>
+          <a:prstGeom prst="line">
+            <a:avLst/>
+          </a:prstGeom>
+          <a:noFill/>
+          <a:ln w="9525">
+            <a:solidFill>
+              <a:srgbClr val="36414F"/>
+            </a:solidFill>
+            <a:prstDash val="solid"/>
+          </a:ln>
+        </p:spPr>
+        <p:txBody>
+          <a:bodyPr/>
+          <a:lstStyle/>
+          <a:p>
+            <a:endParaRPr lang="en-US"/>
           </a:p>
         </p:txBody>
       </p:sp>
@@ -2825,7 +3741,7 @@
       </p:sp>
       <p:pic>
         <p:nvPicPr>
-          <p:cNvPr id="7" name="Image 0" descr="C:/Users/neuma_p1qrsic/Repo/agentic-ops1/.scratch/icons/venue.png">    </p:cNvPr>
+          <p:cNvPr id="7" name="Image 0" descr="C:/Users/neuma_p1qrsic/Repo/agentic-ops1/.scratch/icons/venue.png"/>
           <p:cNvPicPr>
             <a:picLocks noChangeAspect="1"/>
           </p:cNvPicPr>
@@ -2954,7 +3870,7 @@
       </p:sp>
       <p:pic>
         <p:nvPicPr>
-          <p:cNvPr id="11" name="Image 1" descr="C:/Users/neuma_p1qrsic/Repo/agentic-ops1/.scratch/icons/gap.png">    </p:cNvPr>
+          <p:cNvPr id="11" name="Image 1" descr="C:/Users/neuma_p1qrsic/Repo/agentic-ops1/.scratch/icons/gap.png"/>
           <p:cNvPicPr>
             <a:picLocks noChangeAspect="1"/>
           </p:cNvPicPr>
@@ -3113,7 +4029,7 @@
       </p:sp>
       <p:pic>
         <p:nvPicPr>
-          <p:cNvPr id="16" name="Image 2" descr="C:/Users/neuma_p1qrsic/Repo/agentic-ops1/.scratch/icons/database.png">    </p:cNvPr>
+          <p:cNvPr id="16" name="Image 2" descr="C:/Users/neuma_p1qrsic/Repo/agentic-ops1/.scratch/icons/database.png"/>
           <p:cNvPicPr>
             <a:picLocks noChangeAspect="1"/>
           </p:cNvPicPr>
@@ -3294,7 +4210,7 @@
                 <a:ea typeface="Segoe UI" pitchFamily="34" charset="-122"/>
                 <a:cs typeface="Segoe UI" pitchFamily="34" charset="-120"/>
               </a:rPr>
-              <a:t>TreasuryCentral is that middle, so one clean, governed set of data drives every treasury decision on its own.</a:t>
+              <a:t>None of those steps is hard. Together they run a global process on hand-carried data.</a:t>
             </a:r>
             <a:endParaRPr lang="en-US" sz="1600" dirty="0"/>
           </a:p>
@@ -3347,7 +4263,7 @@
                 <a:ea typeface="Segoe UI" pitchFamily="34" charset="-122"/>
                 <a:cs typeface="Segoe UI" pitchFamily="34" charset="-120"/>
               </a:rPr>
-              <a:t>   TreasuryCentral, powered by OnePilot</a:t>
+              <a:t xml:space="preserve">   TreasuryCentral, powered by OnePilot</a:t>
             </a:r>
             <a:endParaRPr lang="en-US" sz="900" dirty="0"/>
           </a:p>
@@ -3386,7 +4302,7 @@
                 <a:ea typeface="Segoe UI" pitchFamily="34" charset="-122"/>
                 <a:cs typeface="Segoe UI" pitchFamily="34" charset="-120"/>
               </a:rPr>
-              <a:t>02 / 10</a:t>
+              <a:t>03 / 11</a:t>
             </a:r>
             <a:endParaRPr lang="en-US" sz="900" dirty="0"/>
           </a:p>
@@ -3586,7 +4502,7 @@
                 <a:ea typeface="Segoe UI" pitchFamily="34" charset="-122"/>
                 <a:cs typeface="Segoe UI" pitchFamily="34" charset="-120"/>
               </a:rPr>
-              <a:t>The command center your team runs treasury from, on live SAP data, with market data, trading, and AI automation and orchestration around it. </a:t>
+              <a:t xml:space="preserve">The command center your team runs treasury from, on live SAP data, with market data, trading, and AI automation and orchestration around it. </a:t>
             </a:r>
             <a:pPr indent="0" marL="0">
               <a:lnSpc>
@@ -3665,7 +4581,7 @@
       </p:sp>
       <p:pic>
         <p:nvPicPr>
-          <p:cNvPr id="8" name="Image 0" descr="C:/Users/neuma_p1qrsic/Repo/agentic-ops1/.scratch/icons/link.png">    </p:cNvPr>
+          <p:cNvPr id="8" name="Image 0" descr="C:/Users/neuma_p1qrsic/Repo/agentic-ops1/.scratch/icons/link.png"/>
           <p:cNvPicPr>
             <a:picLocks noChangeAspect="1"/>
           </p:cNvPicPr>
@@ -3824,7 +4740,7 @@
       </p:sp>
       <p:pic>
         <p:nvPicPr>
-          <p:cNvPr id="13" name="Image 1" descr="C:/Users/neuma_p1qrsic/Repo/agentic-ops1/.scratch/icons/merge.png">    </p:cNvPr>
+          <p:cNvPr id="13" name="Image 1" descr="C:/Users/neuma_p1qrsic/Repo/agentic-ops1/.scratch/icons/merge.png"/>
           <p:cNvPicPr>
             <a:picLocks noChangeAspect="1"/>
           </p:cNvPicPr>
@@ -3983,7 +4899,7 @@
       </p:sp>
       <p:pic>
         <p:nvPicPr>
-          <p:cNvPr id="18" name="Image 2" descr="C:/Users/neuma_p1qrsic/Repo/agentic-ops1/.scratch/icons/spark.png">    </p:cNvPr>
+          <p:cNvPr id="18" name="Image 2" descr="C:/Users/neuma_p1qrsic/Repo/agentic-ops1/.scratch/icons/spark.png"/>
           <p:cNvPicPr>
             <a:picLocks noChangeAspect="1"/>
           </p:cNvPicPr>
@@ -4115,7 +5031,7 @@
       </p:sp>
       <p:pic>
         <p:nvPicPr>
-          <p:cNvPr id="22" name="Image 3" descr="C:/Users/neuma_p1qrsic/Repo/agentic-ops1/.scratch/logo/favicon.png">    </p:cNvPr>
+          <p:cNvPr id="22" name="Image 3" descr="C:/Users/neuma_p1qrsic/Repo/agentic-ops1/.scratch/logo/favicon.png"/>
           <p:cNvPicPr>
             <a:picLocks noChangeAspect="1"/>
           </p:cNvPicPr>
@@ -4173,7 +5089,7 @@
                 <a:ea typeface="Segoe UI" pitchFamily="34" charset="-122"/>
                 <a:cs typeface="Segoe UI" pitchFamily="34" charset="-120"/>
               </a:rPr>
-              <a:t>All of it runs on </a:t>
+              <a:t xml:space="preserve">All of it runs on </a:t>
             </a:r>
             <a:pPr indent="0" marL="0">
               <a:lnSpc>
@@ -4260,7 +5176,7 @@
                 <a:ea typeface="Segoe UI" pitchFamily="34" charset="-122"/>
                 <a:cs typeface="Segoe UI" pitchFamily="34" charset="-120"/>
               </a:rPr>
-              <a:t>   TreasuryCentral, powered by OnePilot</a:t>
+              <a:t xml:space="preserve">   TreasuryCentral, powered by OnePilot</a:t>
             </a:r>
             <a:endParaRPr lang="en-US" sz="900" dirty="0"/>
           </a:p>
@@ -4299,7 +5215,7 @@
                 <a:ea typeface="Segoe UI" pitchFamily="34" charset="-122"/>
                 <a:cs typeface="Segoe UI" pitchFamily="34" charset="-120"/>
               </a:rPr>
-              <a:t>03 / 10</a:t>
+              <a:t>04 / 11</a:t>
             </a:r>
             <a:endParaRPr lang="en-US" sz="900" dirty="0"/>
           </a:p>
@@ -4519,7 +5435,7 @@
       </p:sp>
       <p:pic>
         <p:nvPicPr>
-          <p:cNvPr id="7" name="Image 0" descr="C:/Users/neuma_p1qrsic/Repo/agentic-ops1/.scratch/icons/link.png">    </p:cNvPr>
+          <p:cNvPr id="7" name="Image 0" descr="C:/Users/neuma_p1qrsic/Repo/agentic-ops1/.scratch/icons/link.png"/>
           <p:cNvPicPr>
             <a:picLocks noChangeAspect="1"/>
           </p:cNvPicPr>
@@ -4616,7 +5532,7 @@
                 <a:ea typeface="Segoe UI" pitchFamily="34" charset="-122"/>
                 <a:cs typeface="Segoe UI" pitchFamily="34" charset="-120"/>
               </a:rPr>
-              <a:t>Every rate and reference you rely on, from any source to every system. Curated once, governed end to end.</a:t>
+              <a:t>Every rate and reference you rely on, from any source to every system.</a:t>
             </a:r>
             <a:endParaRPr lang="en-US" sz="1300" dirty="0"/>
           </a:p>
@@ -4651,7 +5567,7 @@
       </p:sp>
       <p:pic>
         <p:nvPicPr>
-          <p:cNvPr id="11" name="Image 1" descr="C:/Users/neuma_p1qrsic/Repo/agentic-ops1/.scratch/deckgen/logos/bloomberg.png">    </p:cNvPr>
+          <p:cNvPr id="11" name="Image 1" descr="C:/Users/neuma_p1qrsic/Repo/agentic-ops1/.scratch/deckgen/logos/bloomberg.png"/>
           <p:cNvPicPr>
             <a:picLocks noChangeAspect="1"/>
           </p:cNvPicPr>
@@ -4702,7 +5618,7 @@
       </p:sp>
       <p:pic>
         <p:nvPicPr>
-          <p:cNvPr id="13" name="Image 2" descr="C:/Users/neuma_p1qrsic/Repo/agentic-ops1/.scratch/deckgen/logos/lseg.png">    </p:cNvPr>
+          <p:cNvPr id="13" name="Image 2" descr="C:/Users/neuma_p1qrsic/Repo/agentic-ops1/.scratch/deckgen/logos/lseg.png"/>
           <p:cNvPicPr>
             <a:picLocks noChangeAspect="1"/>
           </p:cNvPicPr>
@@ -4753,7 +5669,7 @@
       </p:sp>
       <p:pic>
         <p:nvPicPr>
-          <p:cNvPr id="15" name="Image 3" descr="C:/Users/neuma_p1qrsic/Repo/agentic-ops1/.scratch/deckgen/logos/ice.png">    </p:cNvPr>
+          <p:cNvPr id="15" name="Image 3" descr="C:/Users/neuma_p1qrsic/Repo/agentic-ops1/.scratch/deckgen/logos/ice.png"/>
           <p:cNvPicPr>
             <a:picLocks noChangeAspect="1"/>
           </p:cNvPicPr>
@@ -4804,7 +5720,7 @@
       </p:sp>
       <p:pic>
         <p:nvPicPr>
-          <p:cNvPr id="17" name="Image 4" descr="C:/Users/neuma_p1qrsic/Repo/agentic-ops1/.scratch/deckgen/logos/cme.png">    </p:cNvPr>
+          <p:cNvPr id="17" name="Image 4" descr="C:/Users/neuma_p1qrsic/Repo/agentic-ops1/.scratch/deckgen/logos/cme.png"/>
           <p:cNvPicPr>
             <a:picLocks noChangeAspect="1"/>
           </p:cNvPicPr>
@@ -4882,7 +5798,7 @@
       </p:sp>
       <p:pic>
         <p:nvPicPr>
-          <p:cNvPr id="20" name="Image 5" descr="C:/Users/neuma_p1qrsic/Repo/agentic-ops1/.scratch/icons/merge.png">    </p:cNvPr>
+          <p:cNvPr id="20" name="Image 5" descr="C:/Users/neuma_p1qrsic/Repo/agentic-ops1/.scratch/icons/merge.png"/>
           <p:cNvPicPr>
             <a:picLocks noChangeAspect="1"/>
           </p:cNvPicPr>
@@ -5041,7 +5957,7 @@
       </p:sp>
       <p:pic>
         <p:nvPicPr>
-          <p:cNvPr id="25" name="Image 6" descr="C:/Users/neuma_p1qrsic/Repo/agentic-ops1/.scratch/icons/spark.png">    </p:cNvPr>
+          <p:cNvPr id="25" name="Image 6" descr="C:/Users/neuma_p1qrsic/Repo/agentic-ops1/.scratch/icons/spark.png"/>
           <p:cNvPicPr>
             <a:picLocks noChangeAspect="1"/>
           </p:cNvPicPr>
@@ -5191,7 +6107,7 @@
                 <a:ea typeface="Segoe UI" pitchFamily="34" charset="-122"/>
                 <a:cs typeface="Segoe UI" pitchFamily="34" charset="-120"/>
               </a:rPr>
-              <a:t>   TreasuryCentral, powered by OnePilot</a:t>
+              <a:t xml:space="preserve">   TreasuryCentral, powered by OnePilot</a:t>
             </a:r>
             <a:endParaRPr lang="en-US" sz="900" dirty="0"/>
           </a:p>
@@ -5230,7 +6146,7 @@
                 <a:ea typeface="Segoe UI" pitchFamily="34" charset="-122"/>
                 <a:cs typeface="Segoe UI" pitchFamily="34" charset="-120"/>
               </a:rPr>
-              <a:t>04 / 10</a:t>
+              <a:t>05 / 11</a:t>
             </a:r>
             <a:endParaRPr lang="en-US" sz="900" dirty="0"/>
           </a:p>
@@ -5450,7 +6366,7 @@
       </p:sp>
       <p:pic>
         <p:nvPicPr>
-          <p:cNvPr id="7" name="Image 0" descr="C:/Users/neuma_p1qrsic/Repo/agentic-ops1/.scratch/icons/venue.png">    </p:cNvPr>
+          <p:cNvPr id="7" name="Image 0" descr="C:/Users/neuma_p1qrsic/Repo/agentic-ops1/.scratch/icons/venue.png"/>
           <p:cNvPicPr>
             <a:picLocks noChangeAspect="1"/>
           </p:cNvPicPr>
@@ -5622,7 +6538,7 @@
       </p:sp>
       <p:pic>
         <p:nvPicPr>
-          <p:cNvPr id="11" name="Image 1" descr="C:/Users/neuma_p1qrsic/Repo/agentic-ops1/.scratch/logo/favicon.png">    </p:cNvPr>
+          <p:cNvPr id="11" name="Image 1" descr="C:/Users/neuma_p1qrsic/Repo/agentic-ops1/.scratch/logo/favicon.png"/>
           <p:cNvPicPr>
             <a:picLocks noChangeAspect="1"/>
           </p:cNvPicPr>
@@ -5840,7 +6756,7 @@
       </p:sp>
       <p:pic>
         <p:nvPicPr>
-          <p:cNvPr id="17" name="Image 2" descr="C:/Users/neuma_p1qrsic/Repo/agentic-ops1/.scratch/icons/database.png">    </p:cNvPr>
+          <p:cNvPr id="17" name="Image 2" descr="C:/Users/neuma_p1qrsic/Repo/agentic-ops1/.scratch/icons/database.png"/>
           <p:cNvPicPr>
             <a:picLocks noChangeAspect="1"/>
           </p:cNvPicPr>
@@ -6062,7 +6978,7 @@
       </p:sp>
       <p:pic>
         <p:nvPicPr>
-          <p:cNvPr id="23" name="Image 3" descr="C:/Users/neuma_p1qrsic/Repo/agentic-ops1/.scratch/icons/shield.png">    </p:cNvPr>
+          <p:cNvPr id="23" name="Image 3" descr="C:/Users/neuma_p1qrsic/Repo/agentic-ops1/.scratch/icons/shield.png"/>
           <p:cNvPicPr>
             <a:picLocks noChangeAspect="1"/>
           </p:cNvPicPr>
@@ -6120,7 +7036,7 @@
                 <a:ea typeface="Segoe UI" pitchFamily="34" charset="-122"/>
                 <a:cs typeface="Segoe UI" pitchFamily="34" charset="-120"/>
               </a:rPr>
-              <a:t>Every value is validated, checked for anomalies and logged: a full audit trail, segregation of duty, no-code rules, ISO 27001 and SOC 1.</a:t>
+              <a:t>Every value through the layer is validated, checked for anomalies and logged. The next page is the full control set.</a:t>
             </a:r>
             <a:endParaRPr lang="en-US" sz="1350" dirty="0"/>
           </a:p>
@@ -6173,7 +7089,7 @@
                 <a:ea typeface="Segoe UI" pitchFamily="34" charset="-122"/>
                 <a:cs typeface="Segoe UI" pitchFamily="34" charset="-120"/>
               </a:rPr>
-              <a:t>   TreasuryCentral, powered by OnePilot</a:t>
+              <a:t xml:space="preserve">   TreasuryCentral, powered by OnePilot</a:t>
             </a:r>
             <a:endParaRPr lang="en-US" sz="900" dirty="0"/>
           </a:p>
@@ -6212,7 +7128,7 @@
                 <a:ea typeface="Segoe UI" pitchFamily="34" charset="-122"/>
                 <a:cs typeface="Segoe UI" pitchFamily="34" charset="-120"/>
               </a:rPr>
-              <a:t>05 / 10</a:t>
+              <a:t>06 / 11</a:t>
             </a:r>
             <a:endParaRPr lang="en-US" sz="900" dirty="0"/>
           </a:p>
@@ -6432,7 +7348,7 @@
       </p:sp>
       <p:pic>
         <p:nvPicPr>
-          <p:cNvPr id="7" name="Image 0" descr="C:/Users/neuma_p1qrsic/Repo/agentic-ops1/.scratch/icons/list.png">    </p:cNvPr>
+          <p:cNvPr id="7" name="Image 0" descr="C:/Users/neuma_p1qrsic/Repo/agentic-ops1/.scratch/icons/list.png"/>
           <p:cNvPicPr>
             <a:picLocks noChangeAspect="1"/>
           </p:cNvPicPr>
@@ -6588,7 +7504,7 @@
       </p:sp>
       <p:pic>
         <p:nvPicPr>
-          <p:cNvPr id="12" name="Image 1" descr="C:/Users/neuma_p1qrsic/Repo/agentic-ops1/.scratch/icons/shield.png">    </p:cNvPr>
+          <p:cNvPr id="12" name="Image 1" descr="C:/Users/neuma_p1qrsic/Repo/agentic-ops1/.scratch/icons/shield.png"/>
           <p:cNvPicPr>
             <a:picLocks noChangeAspect="1"/>
           </p:cNvPicPr>
@@ -6643,7 +7559,7 @@
                 <a:ea typeface="Segoe UI Semibold" pitchFamily="34" charset="-122"/>
                 <a:cs typeface="Segoe UI Semibold" pitchFamily="34" charset="-120"/>
               </a:rPr>
-              <a:t>Segregation of duty</a:t>
+              <a:t>Segregation of duties</a:t>
             </a:r>
             <a:endParaRPr lang="en-US" sz="1650" dirty="0"/>
           </a:p>
@@ -6744,7 +7660,7 @@
       </p:sp>
       <p:pic>
         <p:nvPicPr>
-          <p:cNvPr id="17" name="Image 2" descr="C:/Users/neuma_p1qrsic/Repo/agentic-ops1/.scratch/icons/eye.png">    </p:cNvPr>
+          <p:cNvPr id="17" name="Image 2" descr="C:/Users/neuma_p1qrsic/Repo/agentic-ops1/.scratch/icons/eye.png"/>
           <p:cNvPicPr>
             <a:picLocks noChangeAspect="1"/>
           </p:cNvPicPr>
@@ -6900,7 +7816,7 @@
       </p:sp>
       <p:pic>
         <p:nvPicPr>
-          <p:cNvPr id="22" name="Image 3" descr="C:/Users/neuma_p1qrsic/Repo/agentic-ops1/.scratch/icons/bell.png">    </p:cNvPr>
+          <p:cNvPr id="22" name="Image 3" descr="C:/Users/neuma_p1qrsic/Repo/agentic-ops1/.scratch/icons/bell.png"/>
           <p:cNvPicPr>
             <a:picLocks noChangeAspect="1"/>
           </p:cNvPicPr>
@@ -7056,7 +7972,7 @@
       </p:sp>
       <p:pic>
         <p:nvPicPr>
-          <p:cNvPr id="27" name="Image 4" descr="C:/Users/neuma_p1qrsic/Repo/agentic-ops1/.scratch/icons/blocks.png">    </p:cNvPr>
+          <p:cNvPr id="27" name="Image 4" descr="C:/Users/neuma_p1qrsic/Repo/agentic-ops1/.scratch/icons/blocks.png"/>
           <p:cNvPicPr>
             <a:picLocks noChangeAspect="1"/>
           </p:cNvPicPr>
@@ -7212,7 +8128,7 @@
       </p:sp>
       <p:pic>
         <p:nvPicPr>
-          <p:cNvPr id="32" name="Image 5" descr="C:/Users/neuma_p1qrsic/Repo/agentic-ops1/.scratch/icons/lock.png">    </p:cNvPr>
+          <p:cNvPr id="32" name="Image 5" descr="C:/Users/neuma_p1qrsic/Repo/agentic-ops1/.scratch/icons/lock.png"/>
           <p:cNvPicPr>
             <a:picLocks noChangeAspect="1"/>
           </p:cNvPicPr>
@@ -7359,7 +8275,7 @@
                 <a:ea typeface="Segoe UI" pitchFamily="34" charset="-122"/>
                 <a:cs typeface="Segoe UI" pitchFamily="34" charset="-120"/>
               </a:rPr>
-              <a:t>   TreasuryCentral, powered by OnePilot</a:t>
+              <a:t xml:space="preserve">   TreasuryCentral, powered by OnePilot</a:t>
             </a:r>
             <a:endParaRPr lang="en-US" sz="900" dirty="0"/>
           </a:p>
@@ -7398,7 +8314,7 @@
                 <a:ea typeface="Segoe UI" pitchFamily="34" charset="-122"/>
                 <a:cs typeface="Segoe UI" pitchFamily="34" charset="-120"/>
               </a:rPr>
-              <a:t>06 / 10</a:t>
+              <a:t>07 / 11</a:t>
             </a:r>
             <a:endParaRPr lang="en-US" sz="900" dirty="0"/>
           </a:p>
@@ -7556,7 +8472,7 @@
                 <a:ea typeface="Segoe UI Semibold" pitchFamily="34" charset="-122"/>
                 <a:cs typeface="Segoe UI Semibold" pitchFamily="34" charset="-120"/>
               </a:rPr>
-              <a:t>TreasuryCentral is powered by </a:t>
+              <a:t xml:space="preserve">TreasuryCentral is powered by </a:t>
             </a:r>
             <a:pPr indent="0" marL="0">
               <a:buNone/>
@@ -7640,8 +8556,8 @@
         </p:nvSpPr>
         <p:spPr>
           <a:xfrm>
-            <a:off x="566928" y="3200400"/>
-            <a:ext cx="1992112" cy="1554480"/>
+            <a:off x="566420" y="3200400"/>
+            <a:ext cx="2573972" cy="1554480"/>
           </a:xfrm>
           <a:prstGeom prst="roundRect">
             <a:avLst>
@@ -7661,7 +8577,7 @@
       </p:sp>
       <p:pic>
         <p:nvPicPr>
-          <p:cNvPr id="7" name="Image 0" descr="C:/Users/neuma_p1qrsic/Repo/agentic-ops1/.scratch/icons/database.png">    </p:cNvPr>
+          <p:cNvPr id="7" name="Image 0" descr="C:/Users/neuma_p1qrsic/Repo/agentic-ops1/.scratch/icons/database.png"/>
           <p:cNvPicPr>
             <a:picLocks noChangeAspect="1"/>
           </p:cNvPicPr>
@@ -7675,7 +8591,7 @@
         </p:blipFill>
         <p:spPr>
           <a:xfrm>
-            <a:off x="1252088" y="3493008"/>
+            <a:off x="1542510" y="3493008"/>
             <a:ext cx="621792" cy="621792"/>
           </a:xfrm>
           <a:prstGeom prst="rect">
@@ -7691,8 +8607,8 @@
         </p:nvSpPr>
         <p:spPr>
           <a:xfrm>
-            <a:off x="640080" y="4187952"/>
-            <a:ext cx="1845808" cy="457200"/>
+            <a:off x="709930" y="4187952"/>
+            <a:ext cx="2286952" cy="457200"/>
           </a:xfrm>
           <a:prstGeom prst="rect">
             <a:avLst/>
@@ -7730,8 +8646,8 @@
         </p:nvSpPr>
         <p:spPr>
           <a:xfrm>
-            <a:off x="2833360" y="3200400"/>
-            <a:ext cx="1992112" cy="1554480"/>
+            <a:off x="3394392" y="3200400"/>
+            <a:ext cx="2573972" cy="1554480"/>
           </a:xfrm>
           <a:prstGeom prst="roundRect">
             <a:avLst>
@@ -7751,7 +8667,7 @@
       </p:sp>
       <p:pic>
         <p:nvPicPr>
-          <p:cNvPr id="10" name="Image 1" descr="C:/Users/neuma_p1qrsic/Repo/agentic-ops1/.scratch/icons/sheet.png">    </p:cNvPr>
+          <p:cNvPr id="10" name="Image 1" descr="C:/Users/neuma_p1qrsic/Repo/agentic-ops1/.scratch/icons/sheet.png"/>
           <p:cNvPicPr>
             <a:picLocks noChangeAspect="1"/>
           </p:cNvPicPr>
@@ -7765,7 +8681,7 @@
         </p:blipFill>
         <p:spPr>
           <a:xfrm>
-            <a:off x="3518520" y="3493008"/>
+            <a:off x="4370482" y="3493008"/>
             <a:ext cx="621792" cy="621792"/>
           </a:xfrm>
           <a:prstGeom prst="rect">
@@ -7781,8 +8697,8 @@
         </p:nvSpPr>
         <p:spPr>
           <a:xfrm>
-            <a:off x="2906512" y="4187952"/>
-            <a:ext cx="1845808" cy="457200"/>
+            <a:off x="3537902" y="4187952"/>
+            <a:ext cx="2286952" cy="457200"/>
           </a:xfrm>
           <a:prstGeom prst="rect">
             <a:avLst/>
@@ -7820,8 +8736,8 @@
         </p:nvSpPr>
         <p:spPr>
           <a:xfrm>
-            <a:off x="5099792" y="3200400"/>
-            <a:ext cx="1992112" cy="1554480"/>
+            <a:off x="6222365" y="3200400"/>
+            <a:ext cx="2573972" cy="1554480"/>
           </a:xfrm>
           <a:prstGeom prst="roundRect">
             <a:avLst>
@@ -7841,7 +8757,7 @@
       </p:sp>
       <p:pic>
         <p:nvPicPr>
-          <p:cNvPr id="13" name="Image 2" descr="C:/Users/neuma_p1qrsic/Repo/agentic-ops1/.scratch/icons/mail.png">    </p:cNvPr>
+          <p:cNvPr id="13" name="Image 2" descr="C:/Users/neuma_p1qrsic/Repo/agentic-ops1/.scratch/icons/mail.png"/>
           <p:cNvPicPr>
             <a:picLocks noChangeAspect="1"/>
           </p:cNvPicPr>
@@ -7855,7 +8771,7 @@
         </p:blipFill>
         <p:spPr>
           <a:xfrm>
-            <a:off x="5784952" y="3493008"/>
+            <a:off x="7198455" y="3493008"/>
             <a:ext cx="621792" cy="621792"/>
           </a:xfrm>
           <a:prstGeom prst="rect">
@@ -7871,8 +8787,8 @@
         </p:nvSpPr>
         <p:spPr>
           <a:xfrm>
-            <a:off x="5172944" y="4187952"/>
-            <a:ext cx="1845808" cy="457200"/>
+            <a:off x="6365875" y="4187952"/>
+            <a:ext cx="2286952" cy="457200"/>
           </a:xfrm>
           <a:prstGeom prst="rect">
             <a:avLst/>
@@ -7910,8 +8826,8 @@
         </p:nvSpPr>
         <p:spPr>
           <a:xfrm>
-            <a:off x="7366224" y="3200400"/>
-            <a:ext cx="1992112" cy="1554480"/>
+            <a:off x="9050337" y="3200400"/>
+            <a:ext cx="2573972" cy="1554480"/>
           </a:xfrm>
           <a:prstGeom prst="roundRect">
             <a:avLst>
@@ -7931,7 +8847,7 @@
       </p:sp>
       <p:pic>
         <p:nvPicPr>
-          <p:cNvPr id="16" name="Image 3" descr="C:/Users/neuma_p1qrsic/Repo/agentic-ops1/.scratch/icons/globe.png">    </p:cNvPr>
+          <p:cNvPr id="16" name="Image 3" descr="C:/Users/neuma_p1qrsic/Repo/agentic-ops1/.scratch/icons/globe.png"/>
           <p:cNvPicPr>
             <a:picLocks noChangeAspect="1"/>
           </p:cNvPicPr>
@@ -7945,7 +8861,7 @@
         </p:blipFill>
         <p:spPr>
           <a:xfrm>
-            <a:off x="8051383" y="3493008"/>
+            <a:off x="10026427" y="3493008"/>
             <a:ext cx="621792" cy="621792"/>
           </a:xfrm>
           <a:prstGeom prst="rect">
@@ -7961,8 +8877,8 @@
         </p:nvSpPr>
         <p:spPr>
           <a:xfrm>
-            <a:off x="7439376" y="4187952"/>
-            <a:ext cx="1845808" cy="457200"/>
+            <a:off x="9193847" y="4187952"/>
+            <a:ext cx="2286952" cy="457200"/>
           </a:xfrm>
           <a:prstGeom prst="rect">
             <a:avLst/>
@@ -7994,65 +8910,14 @@
       </p:sp>
       <p:sp>
         <p:nvSpPr>
-          <p:cNvPr id="18" name="Shape 12"/>
-          <p:cNvSpPr/>
-          <p:nvPr/>
-        </p:nvSpPr>
-        <p:spPr>
-          <a:xfrm>
-            <a:off x="9632655" y="3200400"/>
-            <a:ext cx="1992112" cy="1554480"/>
-          </a:xfrm>
-          <a:prstGeom prst="roundRect">
-            <a:avLst>
-              <a:gd name="adj" fmla="val 5882"/>
-            </a:avLst>
-          </a:prstGeom>
-          <a:solidFill>
-            <a:srgbClr val="141A25"/>
-          </a:solidFill>
-          <a:ln w="13970">
-            <a:solidFill>
-              <a:srgbClr val="36414F"/>
-            </a:solidFill>
-            <a:prstDash val="solid"/>
-          </a:ln>
-        </p:spPr>
-      </p:sp>
-      <p:pic>
-        <p:nvPicPr>
-          <p:cNvPr id="19" name="Image 4" descr="C:/Users/neuma_p1qrsic/Repo/agentic-ops1/.scratch/icons/spark.png">    </p:cNvPr>
-          <p:cNvPicPr>
-            <a:picLocks noChangeAspect="1"/>
-          </p:cNvPicPr>
-          <p:nvPr/>
-        </p:nvPicPr>
-        <p:blipFill>
-          <a:blip r:embed="rId5"/>
-          <a:stretch>
-            <a:fillRect/>
-          </a:stretch>
-        </p:blipFill>
-        <p:spPr>
-          <a:xfrm>
-            <a:off x="10317815" y="3493008"/>
-            <a:ext cx="621792" cy="621792"/>
-          </a:xfrm>
-          <a:prstGeom prst="rect">
-            <a:avLst/>
-          </a:prstGeom>
-        </p:spPr>
-      </p:pic>
-      <p:sp>
-        <p:nvSpPr>
-          <p:cNvPr id="20" name="Text 13"/>
-          <p:cNvSpPr/>
-          <p:nvPr/>
-        </p:nvSpPr>
-        <p:spPr>
-          <a:xfrm>
-            <a:off x="9705807" y="4187952"/>
-            <a:ext cx="1845808" cy="457200"/>
+          <p:cNvPr id="21" name="Text 14"/>
+          <p:cNvSpPr/>
+          <p:nvPr/>
+        </p:nvSpPr>
+        <p:spPr>
+          <a:xfrm>
+            <a:off x="566928" y="5120640"/>
+            <a:ext cx="11057839" cy="457200"/>
           </a:xfrm>
           <a:prstGeom prst="rect">
             <a:avLst/>
@@ -8064,64 +8929,64 @@
           <a:bodyPr wrap="square" rtlCol="0" anchor="ctr"/>
           <a:lstStyle/>
           <a:p>
-            <a:pPr algn="ctr" indent="0" marL="0">
-              <a:buNone/>
-            </a:pPr>
-            <a:r>
-              <a:rPr lang="en-US" sz="1300" dirty="0">
-                <a:solidFill>
-                  <a:srgbClr val="F3F6FB"/>
+            <a:pPr indent="0" marL="0">
+              <a:buNone/>
+            </a:pPr>
+            <a:r>
+              <a:rPr lang="en-US" sz="1500" b="1" dirty="0">
+                <a:solidFill>
+                  <a:srgbClr val="3BE3E0"/>
                 </a:solidFill>
                 <a:latin typeface="Segoe UI" pitchFamily="34" charset="0"/>
                 <a:ea typeface="Segoe UI" pitchFamily="34" charset="-122"/>
                 <a:cs typeface="Segoe UI" pitchFamily="34" charset="-120"/>
               </a:rPr>
-              <a:t>AI</a:t>
-            </a:r>
-            <a:endParaRPr lang="en-US" sz="1300" dirty="0"/>
-          </a:p>
-        </p:txBody>
-      </p:sp>
-      <p:sp>
-        <p:nvSpPr>
-          <p:cNvPr id="21" name="Text 14"/>
-          <p:cNvSpPr/>
-          <p:nvPr/>
-        </p:nvSpPr>
-        <p:spPr>
-          <a:xfrm>
-            <a:off x="566928" y="5120640"/>
-            <a:ext cx="11057839" cy="457200"/>
-          </a:xfrm>
-          <a:prstGeom prst="rect">
-            <a:avLst/>
-          </a:prstGeom>
-          <a:noFill/>
-          <a:ln/>
-        </p:spPr>
-        <p:txBody>
-          <a:bodyPr wrap="square" rtlCol="0" anchor="ctr"/>
-          <a:lstStyle/>
-          <a:p>
+              <a:t xml:space="preserve">Live in weeks, not a rebuild. </a:t>
+            </a:r>
             <a:pPr indent="0" marL="0">
               <a:buNone/>
             </a:pPr>
             <a:r>
-              <a:rPr lang="en-US" sz="1500" b="1" dirty="0">
-                <a:solidFill>
-                  <a:srgbClr val="3BE3E0"/>
+              <a:rPr lang="en-US" sz="1500" dirty="0">
+                <a:solidFill>
+                  <a:srgbClr val="AAB6C7"/>
                 </a:solidFill>
                 <a:latin typeface="Segoe UI" pitchFamily="34" charset="0"/>
                 <a:ea typeface="Segoe UI" pitchFamily="34" charset="-122"/>
                 <a:cs typeface="Segoe UI" pitchFamily="34" charset="-120"/>
               </a:rPr>
-              <a:t>Live in weeks, not a rebuild. </a:t>
-            </a:r>
-            <a:pPr indent="0" marL="0">
-              <a:buNone/>
-            </a:pPr>
-            <a:r>
-              <a:rPr lang="en-US" sz="1500" dirty="0">
+              <a:t>It sits inside your SAP landscape, not beside it.</a:t>
+            </a:r>
+            <a:endParaRPr lang="en-US" sz="1500" dirty="0"/>
+          </a:p>
+        </p:txBody>
+      </p:sp>
+      <p:sp>
+        <p:nvSpPr>
+          <p:cNvPr id="22" name="Text 15"/>
+          <p:cNvSpPr/>
+          <p:nvPr/>
+        </p:nvSpPr>
+        <p:spPr>
+          <a:xfrm>
+            <a:off x="566928" y="6400800"/>
+            <a:ext cx="8229600" cy="274320"/>
+          </a:xfrm>
+          <a:prstGeom prst="rect">
+            <a:avLst/>
+          </a:prstGeom>
+          <a:noFill/>
+          <a:ln/>
+        </p:spPr>
+        <p:txBody>
+          <a:bodyPr wrap="square" rtlCol="0" anchor="ctr"/>
+          <a:lstStyle/>
+          <a:p>
+            <a:pPr algn="l" indent="0" marL="0">
+              <a:buNone/>
+            </a:pPr>
+            <a:r>
+              <a:rPr lang="en-US" sz="900" b="1" dirty="0">
                 <a:solidFill>
                   <a:srgbClr val="AAB6C7"/>
                 </a:solidFill>
@@ -8129,99 +8994,60 @@
                 <a:ea typeface="Segoe UI" pitchFamily="34" charset="-122"/>
                 <a:cs typeface="Segoe UI" pitchFamily="34" charset="-120"/>
               </a:rPr>
-              <a:t>It sits inside your SAP landscape, not beside it.</a:t>
-            </a:r>
-            <a:endParaRPr lang="en-US" sz="1500" dirty="0"/>
-          </a:p>
-        </p:txBody>
-      </p:sp>
-      <p:sp>
-        <p:nvSpPr>
-          <p:cNvPr id="22" name="Text 15"/>
-          <p:cNvSpPr/>
-          <p:nvPr/>
-        </p:nvSpPr>
-        <p:spPr>
-          <a:xfrm>
-            <a:off x="566928" y="6400800"/>
-            <a:ext cx="8229600" cy="274320"/>
-          </a:xfrm>
-          <a:prstGeom prst="rect">
-            <a:avLst/>
-          </a:prstGeom>
-          <a:noFill/>
-          <a:ln/>
-        </p:spPr>
-        <p:txBody>
-          <a:bodyPr wrap="square" rtlCol="0" anchor="ctr"/>
-          <a:lstStyle/>
-          <a:p>
+              <a:t>Brisken</a:t>
+            </a:r>
             <a:pPr algn="l" indent="0" marL="0">
               <a:buNone/>
             </a:pPr>
             <a:r>
-              <a:rPr lang="en-US" sz="900" b="1" dirty="0">
-                <a:solidFill>
-                  <a:srgbClr val="AAB6C7"/>
+              <a:rPr lang="en-US" sz="900" dirty="0">
+                <a:solidFill>
+                  <a:srgbClr val="7C8A9B"/>
                 </a:solidFill>
                 <a:latin typeface="Segoe UI" pitchFamily="34" charset="0"/>
                 <a:ea typeface="Segoe UI" pitchFamily="34" charset="-122"/>
                 <a:cs typeface="Segoe UI" pitchFamily="34" charset="-120"/>
               </a:rPr>
-              <a:t>Brisken</a:t>
-            </a:r>
-            <a:pPr algn="l" indent="0" marL="0">
+              <a:t xml:space="preserve">   TreasuryCentral, powered by OnePilot</a:t>
+            </a:r>
+            <a:endParaRPr lang="en-US" sz="900" dirty="0"/>
+          </a:p>
+        </p:txBody>
+      </p:sp>
+      <p:sp>
+        <p:nvSpPr>
+          <p:cNvPr id="23" name="Text 16"/>
+          <p:cNvSpPr/>
+          <p:nvPr/>
+        </p:nvSpPr>
+        <p:spPr>
+          <a:xfrm>
+            <a:off x="10527487" y="6400800"/>
+            <a:ext cx="1097280" cy="274320"/>
+          </a:xfrm>
+          <a:prstGeom prst="rect">
+            <a:avLst/>
+          </a:prstGeom>
+          <a:noFill/>
+          <a:ln/>
+        </p:spPr>
+        <p:txBody>
+          <a:bodyPr wrap="square" rtlCol="0" anchor="ctr"/>
+          <a:lstStyle/>
+          <a:p>
+            <a:pPr algn="r" indent="0" marL="0">
               <a:buNone/>
             </a:pPr>
             <a:r>
               <a:rPr lang="en-US" sz="900" dirty="0">
                 <a:solidFill>
-                  <a:srgbClr val="7C8A9B"/>
+                  <a:srgbClr val="AAB6C7"/>
                 </a:solidFill>
                 <a:latin typeface="Segoe UI" pitchFamily="34" charset="0"/>
                 <a:ea typeface="Segoe UI" pitchFamily="34" charset="-122"/>
                 <a:cs typeface="Segoe UI" pitchFamily="34" charset="-120"/>
               </a:rPr>
-              <a:t>   TreasuryCentral, powered by OnePilot</a:t>
-            </a:r>
-            <a:endParaRPr lang="en-US" sz="900" dirty="0"/>
-          </a:p>
-        </p:txBody>
-      </p:sp>
-      <p:sp>
-        <p:nvSpPr>
-          <p:cNvPr id="23" name="Text 16"/>
-          <p:cNvSpPr/>
-          <p:nvPr/>
-        </p:nvSpPr>
-        <p:spPr>
-          <a:xfrm>
-            <a:off x="10527487" y="6400800"/>
-            <a:ext cx="1097280" cy="274320"/>
-          </a:xfrm>
-          <a:prstGeom prst="rect">
-            <a:avLst/>
-          </a:prstGeom>
-          <a:noFill/>
-          <a:ln/>
-        </p:spPr>
-        <p:txBody>
-          <a:bodyPr wrap="square" rtlCol="0" anchor="ctr"/>
-          <a:lstStyle/>
-          <a:p>
-            <a:pPr algn="r" indent="0" marL="0">
-              <a:buNone/>
-            </a:pPr>
-            <a:r>
-              <a:rPr lang="en-US" sz="900" dirty="0">
-                <a:solidFill>
-                  <a:srgbClr val="AAB6C7"/>
-                </a:solidFill>
-                <a:latin typeface="Segoe UI" pitchFamily="34" charset="0"/>
-                <a:ea typeface="Segoe UI" pitchFamily="34" charset="-122"/>
-                <a:cs typeface="Segoe UI" pitchFamily="34" charset="-120"/>
-              </a:rPr>
-              <a:t>07 / 10</a:t>
+              <a:t>08 / 11</a:t>
             </a:r>
             <a:endParaRPr lang="en-US" sz="900" dirty="0"/>
           </a:p>
@@ -8284,7 +9110,7 @@
       </p:grpSpPr>
       <p:pic>
         <p:nvPicPr>
-          <p:cNvPr id="2" name="Image 0" descr="C:/Users/neuma_p1qrsic/Repo/agentic-ops1/.scratch/logo/favicon.png">    </p:cNvPr>
+          <p:cNvPr id="2" name="Image 0" descr="C:/Users/neuma_p1qrsic/Repo/agentic-ops1/.scratch/logo/favicon.png"/>
           <p:cNvPicPr>
             <a:picLocks noChangeAspect="1"/>
           </p:cNvPicPr>
@@ -8403,7 +9229,7 @@
                 <a:ea typeface="Segoe UI Semibold" pitchFamily="34" charset="-122"/>
                 <a:cs typeface="Segoe UI Semibold" pitchFamily="34" charset="-120"/>
               </a:rPr>
-              <a:t>Live with customers today, not on a roadmap.</a:t>
+              <a:t>Customer treasuries run on it today.</a:t>
             </a:r>
             <a:endParaRPr lang="en-US" sz="2900" dirty="0"/>
           </a:p>
@@ -8445,7 +9271,7 @@
                 <a:ea typeface="Segoe UI" pitchFamily="34" charset="-122"/>
                 <a:cs typeface="Segoe UI" pitchFamily="34" charset="-120"/>
               </a:rPr>
-              <a:t>Teams like Evonik and RWZ build on OnePilot directly, SAP and non-SAP, on-prem included, and move at the speed of their own ideas rather than a vendor roadmap.</a:t>
+              <a:t>Customer teams build on OnePilot directly, SAP and non-SAP, on-prem included, and move at the speed of their own ideas rather than a vendor roadmap.</a:t>
             </a:r>
             <a:endParaRPr lang="en-US" sz="1600" dirty="0"/>
           </a:p>
@@ -8480,7 +9306,7 @@
       </p:sp>
       <p:pic>
         <p:nvPicPr>
-          <p:cNvPr id="8" name="Image 1" descr="C:/Users/neuma_p1qrsic/Repo/agentic-ops1/.scratch/icons/target.png">    </p:cNvPr>
+          <p:cNvPr id="8" name="Image 1" descr="C:/Users/neuma_p1qrsic/Repo/agentic-ops1/.scratch/icons/target.png"/>
           <p:cNvPicPr>
             <a:picLocks noChangeAspect="1"/>
           </p:cNvPicPr>
@@ -8538,7 +9364,7 @@
                 <a:ea typeface="Segoe UI" pitchFamily="34" charset="-122"/>
                 <a:cs typeface="Segoe UI" pitchFamily="34" charset="-120"/>
               </a:rPr>
-              <a:t>Standardise the process once, governed and analytics-ready, and run it the same way across the whole group.</a:t>
+              <a:t>Standardize the process once, governed and analytics-ready, and run it the same way across the whole group.</a:t>
             </a:r>
             <a:endParaRPr lang="en-US" sz="1550" dirty="0"/>
           </a:p>
@@ -8573,7 +9399,7 @@
       </p:sp>
       <p:pic>
         <p:nvPicPr>
-          <p:cNvPr id="11" name="Image 2" descr="C:/Users/neuma_p1qrsic/Repo/agentic-ops1/.scratch/deckgen/logos/sap.png">    </p:cNvPr>
+          <p:cNvPr id="11" name="Image 2" descr="C:/Users/neuma_p1qrsic/Repo/agentic-ops1/.scratch/deckgen/logos/sap.png"/>
           <p:cNvPicPr>
             <a:picLocks noChangeAspect="1"/>
           </p:cNvPicPr>
@@ -8597,65 +9423,14 @@
       </p:pic>
       <p:sp>
         <p:nvSpPr>
-          <p:cNvPr id="12" name="Shape 7"/>
+          <p:cNvPr id="12" name="Text 7"/>
           <p:cNvSpPr/>
           <p:nvPr/>
         </p:nvSpPr>
         <p:spPr>
           <a:xfrm>
             <a:off x="2304288" y="4754880"/>
-            <a:ext cx="1554480" cy="658368"/>
-          </a:xfrm>
-          <a:prstGeom prst="roundRect">
-            <a:avLst>
-              <a:gd name="adj" fmla="val 19444"/>
-            </a:avLst>
-          </a:prstGeom>
-          <a:solidFill>
-            <a:srgbClr val="FFFFFF"/>
-          </a:solidFill>
-          <a:ln w="9525">
-            <a:solidFill>
-              <a:srgbClr val="36414F"/>
-            </a:solidFill>
-            <a:prstDash val="solid"/>
-          </a:ln>
-        </p:spPr>
-      </p:sp>
-      <p:pic>
-        <p:nvPicPr>
-          <p:cNvPr id="13" name="Image 3" descr="C:/Users/neuma_p1qrsic/Repo/agentic-ops1/.scratch/deckgen/logos/evonik.png">    </p:cNvPr>
-          <p:cNvPicPr>
-            <a:picLocks noChangeAspect="1"/>
-          </p:cNvPicPr>
-          <p:nvPr/>
-        </p:nvPicPr>
-        <p:blipFill>
-          <a:blip r:embed="rId4"/>
-          <a:stretch>
-            <a:fillRect/>
-          </a:stretch>
-        </p:blipFill>
-        <p:spPr>
-          <a:xfrm>
-            <a:off x="2444191" y="4919751"/>
-            <a:ext cx="1274674" cy="328627"/>
-          </a:xfrm>
-          <a:prstGeom prst="rect">
-            <a:avLst/>
-          </a:prstGeom>
-        </p:spPr>
-      </p:pic>
-      <p:sp>
-        <p:nvSpPr>
-          <p:cNvPr id="14" name="Text 8"/>
-          <p:cNvSpPr/>
-          <p:nvPr/>
-        </p:nvSpPr>
-        <p:spPr>
-          <a:xfrm>
-            <a:off x="4178808" y="4754880"/>
-            <a:ext cx="7445959" cy="658368"/>
+            <a:ext cx="9320479" cy="658368"/>
           </a:xfrm>
           <a:prstGeom prst="rect">
             <a:avLst/>
@@ -8682,7 +9457,7 @@
                 <a:ea typeface="Segoe UI" pitchFamily="34" charset="-122"/>
                 <a:cs typeface="Segoe UI" pitchFamily="34" charset="-120"/>
               </a:rPr>
-              <a:t>An SAP co-innovation partner. The cockpit runs on SAP's own cloud, so it sits inside your landscape.</a:t>
+              <a:t>Built with SAP as a co-innovation partner; intercompany funding and remittance advice already run in production.</a:t>
             </a:r>
             <a:endParaRPr lang="en-US" sz="1300" dirty="0"/>
           </a:p>
@@ -8690,7 +9465,7 @@
       </p:sp>
       <p:sp>
         <p:nvSpPr>
-          <p:cNvPr id="15" name="Text 9"/>
+          <p:cNvPr id="13" name="Text 8"/>
           <p:cNvSpPr/>
           <p:nvPr/>
         </p:nvSpPr>
@@ -8735,7 +9510,7 @@
                 <a:ea typeface="Segoe UI" pitchFamily="34" charset="-122"/>
                 <a:cs typeface="Segoe UI" pitchFamily="34" charset="-120"/>
               </a:rPr>
-              <a:t>   TreasuryCentral, powered by OnePilot</a:t>
+              <a:t xml:space="preserve">   TreasuryCentral, powered by OnePilot</a:t>
             </a:r>
             <a:endParaRPr lang="en-US" sz="900" dirty="0"/>
           </a:p>
@@ -8743,7 +9518,7 @@
       </p:sp>
       <p:sp>
         <p:nvSpPr>
-          <p:cNvPr id="16" name="Text 10"/>
+          <p:cNvPr id="14" name="Text 9"/>
           <p:cNvSpPr/>
           <p:nvPr/>
         </p:nvSpPr>
@@ -8774,7 +9549,7 @@
                 <a:ea typeface="Segoe UI" pitchFamily="34" charset="-122"/>
                 <a:cs typeface="Segoe UI" pitchFamily="34" charset="-120"/>
               </a:rPr>
-              <a:t>08 / 10</a:t>
+              <a:t>09 / 11</a:t>
             </a:r>
             <a:endParaRPr lang="en-US" sz="900" dirty="0"/>
           </a:p>
@@ -8782,7 +9557,7 @@
       </p:sp>
       <p:sp>
         <p:nvSpPr>
-          <p:cNvPr id="17" name="Shape 11"/>
+          <p:cNvPr id="15" name="Shape 10"/>
           <p:cNvSpPr/>
           <p:nvPr/>
         </p:nvSpPr>
@@ -8837,7 +9612,7 @@
       </p:grpSpPr>
       <p:pic>
         <p:nvPicPr>
-          <p:cNvPr id="2" name="Image 0" descr="C:/Users/neuma_p1qrsic/Repo/agentic-ops1/.scratch/logo/favicon.png">    </p:cNvPr>
+          <p:cNvPr id="2" name="Image 0" descr="C:/Users/neuma_p1qrsic/Repo/agentic-ops1/.scratch/logo/favicon.png"/>
           <p:cNvPicPr>
             <a:picLocks noChangeAspect="1"/>
           </p:cNvPicPr>
@@ -9018,7 +9793,7 @@
       </p:sp>
       <p:pic>
         <p:nvPicPr>
-          <p:cNvPr id="8" name="Image 1" descr="C:/Users/neuma_p1qrsic/Repo/agentic-ops1/.scratch/icons/shield.png">    </p:cNvPr>
+          <p:cNvPr id="8" name="Image 1" descr="C:/Users/neuma_p1qrsic/Repo/agentic-ops1/.scratch/icons/shield.png"/>
           <p:cNvPicPr>
             <a:picLocks noChangeAspect="1"/>
           </p:cNvPicPr>
@@ -9177,7 +9952,7 @@
       </p:sp>
       <p:pic>
         <p:nvPicPr>
-          <p:cNvPr id="13" name="Image 2" descr="C:/Users/neuma_p1qrsic/Repo/agentic-ops1/.scratch/icons/globe.png">    </p:cNvPr>
+          <p:cNvPr id="13" name="Image 2" descr="C:/Users/neuma_p1qrsic/Repo/agentic-ops1/.scratch/icons/globe.png"/>
           <p:cNvPicPr>
             <a:picLocks noChangeAspect="1"/>
           </p:cNvPicPr>
@@ -9336,7 +10111,7 @@
       </p:sp>
       <p:pic>
         <p:nvPicPr>
-          <p:cNvPr id="18" name="Image 3" descr="C:/Users/neuma_p1qrsic/Repo/agentic-ops1/.scratch/icons/blocks.png">    </p:cNvPr>
+          <p:cNvPr id="18" name="Image 3" descr="C:/Users/neuma_p1qrsic/Repo/agentic-ops1/.scratch/icons/blocks.png"/>
           <p:cNvPicPr>
             <a:picLocks noChangeAspect="1"/>
           </p:cNvPicPr>
@@ -9720,7 +10495,7 @@
                 <a:ea typeface="Segoe UI" pitchFamily="34" charset="-122"/>
                 <a:cs typeface="Segoe UI" pitchFamily="34" charset="-120"/>
               </a:rPr>
-              <a:t>   TreasuryCentral, powered by OnePilot</a:t>
+              <a:t xml:space="preserve">   TreasuryCentral, powered by OnePilot</a:t>
             </a:r>
             <a:endParaRPr lang="en-US" sz="900" dirty="0"/>
           </a:p>
@@ -9759,7 +10534,7 @@
                 <a:ea typeface="Segoe UI" pitchFamily="34" charset="-122"/>
                 <a:cs typeface="Segoe UI" pitchFamily="34" charset="-120"/>
               </a:rPr>
-              <a:t>09 / 10</a:t>
+              <a:t>10 / 11</a:t>
             </a:r>
             <a:endParaRPr lang="en-US" sz="900" dirty="0"/>
           </a:p>
@@ -10089,4 +10864,310 @@
     </a:ext>
   </a:extLst>
 </a:theme>
+</file>
+
+<file path=customXml/item1.xml><?xml version="1.0" encoding="utf-8"?>
+<ct:contentTypeSchema xmlns:ct="http://schemas.microsoft.com/office/2006/metadata/contentType" xmlns:ma="http://schemas.microsoft.com/office/2006/metadata/properties/metaAttributes" ct:_="" ma:_="" ma:contentTypeName="Dokument" ma:contentTypeID="0x0101002E36004C6954FC41BFA5A9934AAC0872" ma:contentTypeVersion="24" ma:contentTypeDescription="Ein neues Dokument erstellen." ma:contentTypeScope="" ma:versionID="57c7552af7d6b5cd23556c588442084f">
+  <xsd:schema xmlns:xsd="http://www.w3.org/2001/XMLSchema" xmlns:xs="http://www.w3.org/2001/XMLSchema" xmlns:p="http://schemas.microsoft.com/office/2006/metadata/properties" xmlns:ns1="http://schemas.microsoft.com/sharepoint/v3" xmlns:ns2="f7c12939-211d-4aac-95d7-b8d38b675650" xmlns:ns3="e9089a15-9498-4149-a6f3-b4bc8e4d21ac" targetNamespace="http://schemas.microsoft.com/office/2006/metadata/properties" ma:root="true" ma:fieldsID="482b58ec50687d4a7ad8377ddd49b85c" ns1:_="" ns2:_="" ns3:_="">
+    <xsd:import namespace="http://schemas.microsoft.com/sharepoint/v3"/>
+    <xsd:import namespace="f7c12939-211d-4aac-95d7-b8d38b675650"/>
+    <xsd:import namespace="e9089a15-9498-4149-a6f3-b4bc8e4d21ac"/>
+    <xsd:element name="properties">
+      <xsd:complexType>
+        <xsd:sequence>
+          <xsd:element name="documentManagement">
+            <xsd:complexType>
+              <xsd:all>
+                <xsd:element ref="ns2:MediaServiceMetadata" minOccurs="0"/>
+                <xsd:element ref="ns2:MediaServiceFastMetadata" minOccurs="0"/>
+                <xsd:element ref="ns2:MediaServiceAutoKeyPoints" minOccurs="0"/>
+                <xsd:element ref="ns2:MediaServiceKeyPoints" minOccurs="0"/>
+                <xsd:element ref="ns2:MediaServiceAutoTags" minOccurs="0"/>
+                <xsd:element ref="ns2:MediaServiceOCR" minOccurs="0"/>
+                <xsd:element ref="ns2:MediaServiceGenerationTime" minOccurs="0"/>
+                <xsd:element ref="ns2:MediaServiceEventHashCode" minOccurs="0"/>
+                <xsd:element ref="ns2:MediaServiceDateTaken" minOccurs="0"/>
+                <xsd:element ref="ns3:SharedWithUsers" minOccurs="0"/>
+                <xsd:element ref="ns3:SharedWithDetails" minOccurs="0"/>
+                <xsd:element ref="ns2:MediaLengthInSeconds" minOccurs="0"/>
+                <xsd:element ref="ns2:MediaServiceLocation" minOccurs="0"/>
+                <xsd:element ref="ns3:TaxCatchAll" minOccurs="0"/>
+                <xsd:element ref="ns2:lcf76f155ced4ddcb4097134ff3c332f" minOccurs="0"/>
+                <xsd:element ref="ns1:_ip_UnifiedCompliancePolicyProperties" minOccurs="0"/>
+                <xsd:element ref="ns1:_ip_UnifiedCompliancePolicyUIAction" minOccurs="0"/>
+                <xsd:element ref="ns2:MediaServiceObjectDetectorVersions" minOccurs="0"/>
+                <xsd:element ref="ns2:MediaServiceSearchProperties" minOccurs="0"/>
+                <xsd:element ref="ns2:MediaServiceBillingMetadata" minOccurs="0"/>
+              </xsd:all>
+            </xsd:complexType>
+          </xsd:element>
+        </xsd:sequence>
+      </xsd:complexType>
+    </xsd:element>
+  </xsd:schema>
+  <xsd:schema xmlns:xsd="http://www.w3.org/2001/XMLSchema" xmlns:xs="http://www.w3.org/2001/XMLSchema" xmlns:dms="http://schemas.microsoft.com/office/2006/documentManagement/types" xmlns:pc="http://schemas.microsoft.com/office/infopath/2007/PartnerControls" targetNamespace="http://schemas.microsoft.com/sharepoint/v3" elementFormDefault="qualified">
+    <xsd:import namespace="http://schemas.microsoft.com/office/2006/documentManagement/types"/>
+    <xsd:import namespace="http://schemas.microsoft.com/office/infopath/2007/PartnerControls"/>
+    <xsd:element name="_ip_UnifiedCompliancePolicyProperties" ma:index="24" nillable="true" ma:displayName="Eigenschaften der einheitlichen Compliancerichtlinie" ma:hidden="true" ma:internalName="_ip_UnifiedCompliancePolicyProperties">
+      <xsd:simpleType>
+        <xsd:restriction base="dms:Note"/>
+      </xsd:simpleType>
+    </xsd:element>
+    <xsd:element name="_ip_UnifiedCompliancePolicyUIAction" ma:index="25" nillable="true" ma:displayName="UI-Aktion der einheitlichen Compliancerichtlinie" ma:hidden="true" ma:internalName="_ip_UnifiedCompliancePolicyUIAction">
+      <xsd:simpleType>
+        <xsd:restriction base="dms:Text"/>
+      </xsd:simpleType>
+    </xsd:element>
+  </xsd:schema>
+  <xsd:schema xmlns:xsd="http://www.w3.org/2001/XMLSchema" xmlns:xs="http://www.w3.org/2001/XMLSchema" xmlns:dms="http://schemas.microsoft.com/office/2006/documentManagement/types" xmlns:pc="http://schemas.microsoft.com/office/infopath/2007/PartnerControls" targetNamespace="f7c12939-211d-4aac-95d7-b8d38b675650" elementFormDefault="qualified">
+    <xsd:import namespace="http://schemas.microsoft.com/office/2006/documentManagement/types"/>
+    <xsd:import namespace="http://schemas.microsoft.com/office/infopath/2007/PartnerControls"/>
+    <xsd:element name="MediaServiceMetadata" ma:index="8" nillable="true" ma:displayName="MediaServiceMetadata" ma:hidden="true" ma:internalName="MediaServiceMetadata" ma:readOnly="true">
+      <xsd:simpleType>
+        <xsd:restriction base="dms:Note"/>
+      </xsd:simpleType>
+    </xsd:element>
+    <xsd:element name="MediaServiceFastMetadata" ma:index="9" nillable="true" ma:displayName="MediaServiceFastMetadata" ma:hidden="true" ma:internalName="MediaServiceFastMetadata" ma:readOnly="true">
+      <xsd:simpleType>
+        <xsd:restriction base="dms:Note"/>
+      </xsd:simpleType>
+    </xsd:element>
+    <xsd:element name="MediaServiceAutoKeyPoints" ma:index="10" nillable="true" ma:displayName="MediaServiceAutoKeyPoints" ma:hidden="true" ma:internalName="MediaServiceAutoKeyPoints" ma:readOnly="true">
+      <xsd:simpleType>
+        <xsd:restriction base="dms:Note"/>
+      </xsd:simpleType>
+    </xsd:element>
+    <xsd:element name="MediaServiceKeyPoints" ma:index="11" nillable="true" ma:displayName="KeyPoints" ma:hidden="true" ma:internalName="MediaServiceKeyPoints" ma:readOnly="true">
+      <xsd:simpleType>
+        <xsd:restriction base="dms:Note"/>
+      </xsd:simpleType>
+    </xsd:element>
+    <xsd:element name="MediaServiceAutoTags" ma:index="12" nillable="true" ma:displayName="Tags" ma:hidden="true" ma:internalName="MediaServiceAutoTags" ma:readOnly="true">
+      <xsd:simpleType>
+        <xsd:restriction base="dms:Text"/>
+      </xsd:simpleType>
+    </xsd:element>
+    <xsd:element name="MediaServiceOCR" ma:index="13" nillable="true" ma:displayName="Extracted Text" ma:hidden="true" ma:internalName="MediaServiceOCR" ma:readOnly="true">
+      <xsd:simpleType>
+        <xsd:restriction base="dms:Note"/>
+      </xsd:simpleType>
+    </xsd:element>
+    <xsd:element name="MediaServiceGenerationTime" ma:index="14" nillable="true" ma:displayName="MediaServiceGenerationTime" ma:hidden="true" ma:internalName="MediaServiceGenerationTime" ma:readOnly="true">
+      <xsd:simpleType>
+        <xsd:restriction base="dms:Text"/>
+      </xsd:simpleType>
+    </xsd:element>
+    <xsd:element name="MediaServiceEventHashCode" ma:index="15" nillable="true" ma:displayName="MediaServiceEventHashCode" ma:hidden="true" ma:internalName="MediaServiceEventHashCode" ma:readOnly="true">
+      <xsd:simpleType>
+        <xsd:restriction base="dms:Text"/>
+      </xsd:simpleType>
+    </xsd:element>
+    <xsd:element name="MediaServiceDateTaken" ma:index="16" nillable="true" ma:displayName="MediaServiceDateTaken" ma:hidden="true" ma:internalName="MediaServiceDateTaken" ma:readOnly="true">
+      <xsd:simpleType>
+        <xsd:restriction base="dms:Text"/>
+      </xsd:simpleType>
+    </xsd:element>
+    <xsd:element name="MediaLengthInSeconds" ma:index="19" nillable="true" ma:displayName="Length (seconds)" ma:hidden="true" ma:internalName="MediaLengthInSeconds" ma:readOnly="true">
+      <xsd:simpleType>
+        <xsd:restriction base="dms:Unknown"/>
+      </xsd:simpleType>
+    </xsd:element>
+    <xsd:element name="MediaServiceLocation" ma:index="20" nillable="true" ma:displayName="Location" ma:hidden="true" ma:internalName="MediaServiceLocation" ma:readOnly="true">
+      <xsd:simpleType>
+        <xsd:restriction base="dms:Text"/>
+      </xsd:simpleType>
+    </xsd:element>
+    <xsd:element name="lcf76f155ced4ddcb4097134ff3c332f" ma:index="23" nillable="true" ma:taxonomy="true" ma:internalName="lcf76f155ced4ddcb4097134ff3c332f" ma:taxonomyFieldName="MediaServiceImageTags" ma:displayName="Bildmarkierungen" ma:readOnly="false" ma:fieldId="{5cf76f15-5ced-4ddc-b409-7134ff3c332f}" ma:taxonomyMulti="true" ma:sspId="0fd6ee07-b435-4fc4-a9c7-316946df4b76" ma:termSetId="09814cd3-568e-fe90-9814-8d621ff8fb84" ma:anchorId="fba54fb3-c3e1-fe81-a776-ca4b69148c4d" ma:open="true" ma:isKeyword="false">
+      <xsd:complexType>
+        <xsd:sequence>
+          <xsd:element ref="pc:Terms" minOccurs="0" maxOccurs="1"/>
+        </xsd:sequence>
+      </xsd:complexType>
+    </xsd:element>
+    <xsd:element name="MediaServiceObjectDetectorVersions" ma:index="26" nillable="true" ma:displayName="MediaServiceObjectDetectorVersions" ma:hidden="true" ma:indexed="true" ma:internalName="MediaServiceObjectDetectorVersions" ma:readOnly="true">
+      <xsd:simpleType>
+        <xsd:restriction base="dms:Text"/>
+      </xsd:simpleType>
+    </xsd:element>
+    <xsd:element name="MediaServiceSearchProperties" ma:index="27" nillable="true" ma:displayName="MediaServiceSearchProperties" ma:hidden="true" ma:internalName="MediaServiceSearchProperties" ma:readOnly="true">
+      <xsd:simpleType>
+        <xsd:restriction base="dms:Note"/>
+      </xsd:simpleType>
+    </xsd:element>
+    <xsd:element name="MediaServiceBillingMetadata" ma:index="28" nillable="true" ma:displayName="MediaServiceBillingMetadata" ma:hidden="true" ma:internalName="MediaServiceBillingMetadata" ma:readOnly="true">
+      <xsd:simpleType>
+        <xsd:restriction base="dms:Note"/>
+      </xsd:simpleType>
+    </xsd:element>
+  </xsd:schema>
+  <xsd:schema xmlns:xsd="http://www.w3.org/2001/XMLSchema" xmlns:xs="http://www.w3.org/2001/XMLSchema" xmlns:dms="http://schemas.microsoft.com/office/2006/documentManagement/types" xmlns:pc="http://schemas.microsoft.com/office/infopath/2007/PartnerControls" targetNamespace="e9089a15-9498-4149-a6f3-b4bc8e4d21ac" elementFormDefault="qualified">
+    <xsd:import namespace="http://schemas.microsoft.com/office/2006/documentManagement/types"/>
+    <xsd:import namespace="http://schemas.microsoft.com/office/infopath/2007/PartnerControls"/>
+    <xsd:element name="SharedWithUsers" ma:index="17" nillable="true" ma:displayName="Freigegeben für" ma:hidden="true" ma:internalName="SharedWithUsers" ma:readOnly="true">
+      <xsd:complexType>
+        <xsd:complexContent>
+          <xsd:extension base="dms:UserMulti">
+            <xsd:sequence>
+              <xsd:element name="UserInfo" minOccurs="0" maxOccurs="unbounded">
+                <xsd:complexType>
+                  <xsd:sequence>
+                    <xsd:element name="DisplayName" type="xsd:string" minOccurs="0"/>
+                    <xsd:element name="AccountId" type="dms:UserId" minOccurs="0" nillable="true"/>
+                    <xsd:element name="AccountType" type="xsd:string" minOccurs="0"/>
+                  </xsd:sequence>
+                </xsd:complexType>
+              </xsd:element>
+            </xsd:sequence>
+          </xsd:extension>
+        </xsd:complexContent>
+      </xsd:complexType>
+    </xsd:element>
+    <xsd:element name="SharedWithDetails" ma:index="18" nillable="true" ma:displayName="Freigegeben für - Details" ma:hidden="true" ma:internalName="SharedWithDetails" ma:readOnly="true">
+      <xsd:simpleType>
+        <xsd:restriction base="dms:Note"/>
+      </xsd:simpleType>
+    </xsd:element>
+    <xsd:element name="TaxCatchAll" ma:index="21" nillable="true" ma:displayName="Taxonomy Catch All Column" ma:hidden="true" ma:list="{3ed79911-b83d-417d-9b12-a1fdc4449e3b}" ma:internalName="TaxCatchAll" ma:showField="CatchAllData" ma:web="e9089a15-9498-4149-a6f3-b4bc8e4d21ac">
+      <xsd:complexType>
+        <xsd:complexContent>
+          <xsd:extension base="dms:MultiChoiceLookup">
+            <xsd:sequence>
+              <xsd:element name="Value" type="dms:Lookup" maxOccurs="unbounded" minOccurs="0" nillable="true"/>
+            </xsd:sequence>
+          </xsd:extension>
+        </xsd:complexContent>
+      </xsd:complexType>
+    </xsd:element>
+  </xsd:schema>
+  <xsd:schema xmlns="http://schemas.openxmlformats.org/package/2006/metadata/core-properties" xmlns:xsd="http://www.w3.org/2001/XMLSchema" xmlns:xsi="http://www.w3.org/2001/XMLSchema-instance" xmlns:dc="http://purl.org/dc/elements/1.1/" xmlns:dcterms="http://purl.org/dc/terms/" xmlns:odoc="http://schemas.microsoft.com/internal/obd" targetNamespace="http://schemas.openxmlformats.org/package/2006/metadata/core-properties" elementFormDefault="qualified" attributeFormDefault="unqualified" blockDefault="#all">
+    <xsd:import namespace="http://purl.org/dc/elements/1.1/" schemaLocation="http://dublincore.org/schemas/xmls/qdc/2003/04/02/dc.xsd"/>
+    <xsd:import namespace="http://purl.org/dc/terms/" schemaLocation="http://dublincore.org/schemas/xmls/qdc/2003/04/02/dcterms.xsd"/>
+    <xsd:element name="coreProperties" type="CT_coreProperties"/>
+    <xsd:complexType name="CT_coreProperties">
+      <xsd:all>
+        <xsd:element ref="dc:creator" minOccurs="0" maxOccurs="1"/>
+        <xsd:element ref="dcterms:created" minOccurs="0" maxOccurs="1"/>
+        <xsd:element ref="dc:identifier" minOccurs="0" maxOccurs="1"/>
+        <xsd:element name="contentType" minOccurs="0" maxOccurs="1" type="xsd:string" ma:displayName="Inhaltstyp"/>
+        <xsd:element ref="dc:title" minOccurs="0" maxOccurs="1" ma:index="1" ma:displayName="Titel"/>
+        <xsd:element ref="dc:subject" minOccurs="0" maxOccurs="1"/>
+        <xsd:element ref="dc:description" minOccurs="0" maxOccurs="1"/>
+        <xsd:element name="keywords" minOccurs="0" maxOccurs="1" type="xsd:string"/>
+        <xsd:element ref="dc:language" minOccurs="0" maxOccurs="1"/>
+        <xsd:element name="category" minOccurs="0" maxOccurs="1" type="xsd:string"/>
+        <xsd:element name="version" minOccurs="0" maxOccurs="1" type="xsd:string"/>
+        <xsd:element name="revision" minOccurs="0" maxOccurs="1" type="xsd:string">
+          <xsd:annotation>
+            <xsd:documentation>
+                        This value indicates the number of saves or revisions. The application is responsible for updating this value after each revision.
+                    </xsd:documentation>
+          </xsd:annotation>
+        </xsd:element>
+        <xsd:element name="lastModifiedBy" minOccurs="0" maxOccurs="1" type="xsd:string"/>
+        <xsd:element ref="dcterms:modified" minOccurs="0" maxOccurs="1"/>
+        <xsd:element name="contentStatus" minOccurs="0" maxOccurs="1" type="xsd:string"/>
+      </xsd:all>
+    </xsd:complexType>
+  </xsd:schema>
+  <xs:schema xmlns:pc="http://schemas.microsoft.com/office/infopath/2007/PartnerControls" xmlns:xs="http://www.w3.org/2001/XMLSchema" targetNamespace="http://schemas.microsoft.com/office/infopath/2007/PartnerControls" elementFormDefault="qualified" attributeFormDefault="unqualified">
+    <xs:element name="Person">
+      <xs:complexType>
+        <xs:sequence>
+          <xs:element ref="pc:DisplayName" minOccurs="0"/>
+          <xs:element ref="pc:AccountId" minOccurs="0"/>
+          <xs:element ref="pc:AccountType" minOccurs="0"/>
+        </xs:sequence>
+      </xs:complexType>
+    </xs:element>
+    <xs:element name="DisplayName" type="xs:string"/>
+    <xs:element name="AccountId" type="xs:string"/>
+    <xs:element name="AccountType" type="xs:string"/>
+    <xs:element name="BDCAssociatedEntity">
+      <xs:complexType>
+        <xs:sequence>
+          <xs:element ref="pc:BDCEntity" minOccurs="0" maxOccurs="unbounded"/>
+        </xs:sequence>
+        <xs:attribute ref="pc:EntityNamespace"/>
+        <xs:attribute ref="pc:EntityName"/>
+        <xs:attribute ref="pc:SystemInstanceName"/>
+        <xs:attribute ref="pc:AssociationName"/>
+      </xs:complexType>
+    </xs:element>
+    <xs:attribute name="EntityNamespace" type="xs:string"/>
+    <xs:attribute name="EntityName" type="xs:string"/>
+    <xs:attribute name="SystemInstanceName" type="xs:string"/>
+    <xs:attribute name="AssociationName" type="xs:string"/>
+    <xs:element name="BDCEntity">
+      <xs:complexType>
+        <xs:sequence>
+          <xs:element ref="pc:EntityDisplayName" minOccurs="0"/>
+          <xs:element ref="pc:EntityInstanceReference" minOccurs="0"/>
+          <xs:element ref="pc:EntityId1" minOccurs="0"/>
+          <xs:element ref="pc:EntityId2" minOccurs="0"/>
+          <xs:element ref="pc:EntityId3" minOccurs="0"/>
+          <xs:element ref="pc:EntityId4" minOccurs="0"/>
+          <xs:element ref="pc:EntityId5" minOccurs="0"/>
+        </xs:sequence>
+      </xs:complexType>
+    </xs:element>
+    <xs:element name="EntityDisplayName" type="xs:string"/>
+    <xs:element name="EntityInstanceReference" type="xs:string"/>
+    <xs:element name="EntityId1" type="xs:string"/>
+    <xs:element name="EntityId2" type="xs:string"/>
+    <xs:element name="EntityId3" type="xs:string"/>
+    <xs:element name="EntityId4" type="xs:string"/>
+    <xs:element name="EntityId5" type="xs:string"/>
+    <xs:element name="Terms">
+      <xs:complexType>
+        <xs:sequence>
+          <xs:element ref="pc:TermInfo" minOccurs="0" maxOccurs="unbounded"/>
+        </xs:sequence>
+      </xs:complexType>
+    </xs:element>
+    <xs:element name="TermInfo">
+      <xs:complexType>
+        <xs:sequence>
+          <xs:element ref="pc:TermName" minOccurs="0"/>
+          <xs:element ref="pc:TermId" minOccurs="0"/>
+        </xs:sequence>
+      </xs:complexType>
+    </xs:element>
+    <xs:element name="TermName" type="xs:string"/>
+    <xs:element name="TermId" type="xs:string"/>
+  </xs:schema>
+</ct:contentTypeSchema>
+</file>
+
+<file path=customXml/item2.xml><?xml version="1.0" encoding="utf-8"?>
+<?mso-contentType ?>
+<FormTemplates xmlns="http://schemas.microsoft.com/sharepoint/v3/contenttype/forms">
+  <Display>DocumentLibraryForm</Display>
+  <Edit>DocumentLibraryForm</Edit>
+  <New>DocumentLibraryForm</New>
+</FormTemplates>
+</file>
+
+<file path=customXml/item3.xml><?xml version="1.0" encoding="utf-8"?>
+<p:properties xmlns:p="http://schemas.microsoft.com/office/2006/metadata/properties" xmlns:xsi="http://www.w3.org/2001/XMLSchema-instance" xmlns:pc="http://schemas.microsoft.com/office/infopath/2007/PartnerControls">
+  <documentManagement>
+    <_ip_UnifiedCompliancePolicyUIAction xmlns="http://schemas.microsoft.com/sharepoint/v3" xsi:nil="true"/>
+    <lcf76f155ced4ddcb4097134ff3c332f xmlns="f7c12939-211d-4aac-95d7-b8d38b675650">
+      <Terms xmlns="http://schemas.microsoft.com/office/infopath/2007/PartnerControls"/>
+    </lcf76f155ced4ddcb4097134ff3c332f>
+    <_ip_UnifiedCompliancePolicyProperties xmlns="http://schemas.microsoft.com/sharepoint/v3" xsi:nil="true"/>
+    <TaxCatchAll xmlns="e9089a15-9498-4149-a6f3-b4bc8e4d21ac" xsi:nil="true"/>
+  </documentManagement>
+</p:properties>
+</file>
+
+<file path=customXml/itemProps1.xml><?xml version="1.0" encoding="utf-8"?>
+<ds:datastoreItem xmlns:ds="http://schemas.openxmlformats.org/officeDocument/2006/customXml" ds:itemID="{7C68BC3F-F588-48C1-BE83-B8733ECF8364}"/>
+</file>
+
+<file path=customXml/itemProps2.xml><?xml version="1.0" encoding="utf-8"?>
+<ds:datastoreItem xmlns:ds="http://schemas.openxmlformats.org/officeDocument/2006/customXml" ds:itemID="{52E8A2B1-84DA-44DD-861F-25079F3A229A}"/>
+</file>
+
+<file path=customXml/itemProps3.xml><?xml version="1.0" encoding="utf-8"?>
+<ds:datastoreItem xmlns:ds="http://schemas.openxmlformats.org/officeDocument/2006/customXml" ds:itemID="{58EBBFD8-AB17-4789-A5A0-F7F7835295BB}"/>
 </file>
</xml_diff>